<commit_message>
docs: improve submission screenshots and clarify planned responsibilities
</commit_message>
<xml_diff>
--- a/docs/presentation.pptx
+++ b/docs/presentation.pptx
@@ -2,22 +2,22 @@
 <file path=ppt/presentation.xml><?xml version="1.0" encoding="utf-8"?>
 <p:presentation xmlns:p="http://schemas.openxmlformats.org/presentationml/2006/main">
   <p:sldMasterIdLst>
-    <p:sldMasterId xmlns:r="http://schemas.openxmlformats.org/officeDocument/2006/relationships" id="2147483648" r:id="R310c6b7cdd3549e4"/>
+    <p:sldMasterId xmlns:r="http://schemas.openxmlformats.org/officeDocument/2006/relationships" id="2147483648" r:id="Rdd5cbfa6be8447fe"/>
   </p:sldMasterIdLst>
   <p:notesMasterIdLst>
-    <p:notesMasterId xmlns:r="http://schemas.openxmlformats.org/officeDocument/2006/relationships" r:id="R04c38deb738d44fb"/>
+    <p:notesMasterId xmlns:r="http://schemas.openxmlformats.org/officeDocument/2006/relationships" r:id="Rdae8a680023042fd"/>
   </p:notesMasterIdLst>
   <p:sldIdLst>
-    <p:sldId xmlns:r="http://schemas.openxmlformats.org/officeDocument/2006/relationships" id="256" r:id="R38841d20e4574354"/>
-    <p:sldId xmlns:r="http://schemas.openxmlformats.org/officeDocument/2006/relationships" id="257" r:id="R48fb7d2f9b714208"/>
-    <p:sldId xmlns:r="http://schemas.openxmlformats.org/officeDocument/2006/relationships" id="258" r:id="Rbf4a8f9766e04749"/>
-    <p:sldId xmlns:r="http://schemas.openxmlformats.org/officeDocument/2006/relationships" id="259" r:id="Rd9ecc196e75a40d8"/>
-    <p:sldId xmlns:r="http://schemas.openxmlformats.org/officeDocument/2006/relationships" id="260" r:id="R4c6e874d7c5c4390"/>
-    <p:sldId xmlns:r="http://schemas.openxmlformats.org/officeDocument/2006/relationships" id="261" r:id="Ra82ec3d48de148ed"/>
-    <p:sldId xmlns:r="http://schemas.openxmlformats.org/officeDocument/2006/relationships" id="262" r:id="R15a244c4395d4f43"/>
-    <p:sldId xmlns:r="http://schemas.openxmlformats.org/officeDocument/2006/relationships" id="263" r:id="R0fd431be33ec4c3e"/>
-    <p:sldId xmlns:r="http://schemas.openxmlformats.org/officeDocument/2006/relationships" id="264" r:id="R62dea6e2dc1f480d"/>
-    <p:sldId xmlns:r="http://schemas.openxmlformats.org/officeDocument/2006/relationships" id="265" r:id="R4352d43f0a064864"/>
+    <p:sldId xmlns:r="http://schemas.openxmlformats.org/officeDocument/2006/relationships" id="256" r:id="R8d030d4a3bbe4f3f"/>
+    <p:sldId xmlns:r="http://schemas.openxmlformats.org/officeDocument/2006/relationships" id="257" r:id="R6acfb19f687448ae"/>
+    <p:sldId xmlns:r="http://schemas.openxmlformats.org/officeDocument/2006/relationships" id="258" r:id="R110016286881442f"/>
+    <p:sldId xmlns:r="http://schemas.openxmlformats.org/officeDocument/2006/relationships" id="259" r:id="R71ca9f09cc3f41ea"/>
+    <p:sldId xmlns:r="http://schemas.openxmlformats.org/officeDocument/2006/relationships" id="260" r:id="R363f72bea75f47d4"/>
+    <p:sldId xmlns:r="http://schemas.openxmlformats.org/officeDocument/2006/relationships" id="261" r:id="Ree879fca39c140be"/>
+    <p:sldId xmlns:r="http://schemas.openxmlformats.org/officeDocument/2006/relationships" id="262" r:id="R2482cb69c4d94fce"/>
+    <p:sldId xmlns:r="http://schemas.openxmlformats.org/officeDocument/2006/relationships" id="263" r:id="R3697711b50d54a41"/>
+    <p:sldId xmlns:r="http://schemas.openxmlformats.org/officeDocument/2006/relationships" id="264" r:id="R3eefa9877de542e8"/>
+    <p:sldId xmlns:r="http://schemas.openxmlformats.org/officeDocument/2006/relationships" id="265" r:id="Rb8c1bb581cde49df"/>
   </p:sldIdLst>
   <p:sldSz cx="12192000" cy="6858000"/>
   <p:notesSz cx="6858000" cy="9144000"/>
@@ -451,37 +451,17 @@
           <a:lstStyle xmlns:a="http://schemas.openxmlformats.org/drawingml/2006/main"/>
           <a:p xmlns:a="http://schemas.openxmlformats.org/drawingml/2006/main">
             <a:r>
-              <a:t>Самир. Слайд 1.</a:t>
-            </a:r>
-          </a:p>
-          <a:p xmlns:a="http://schemas.openxmlformats.org/drawingml/2006/main">
-            <a:r>
-              <a:t/>
-            </a:r>
-          </a:p>
-          <a:p xmlns:a="http://schemas.openxmlformats.org/drawingml/2006/main">
-            <a:r>
-              <a:t>Здравствуйте. Наш проект называется «Учёт оборудования и аудиторий колледжа». Приложение помогает найти технику, подать заявку и записать выдачу или возврат. Ещё можно проверить наличие предметов в аудитории. Мы работали вдвоём. Я расскажу об интерфейсе и запуске, Артём объяснит устройство сервера и базы данных.</a:t>
-            </a:r>
-          </a:p>
-          <a:p xmlns:a="http://schemas.openxmlformats.org/drawingml/2006/main">
-            <a:r>
-              <a:t/>
-            </a:r>
-          </a:p>
-          <a:p xmlns:a="http://schemas.openxmlformats.org/drawingml/2006/main">
-            <a:r>
               <a:t>Материалы проекта: https://github.com/Samirrrrr123/college-inventory</a:t>
             </a:r>
           </a:p>
           <a:p xmlns:a="http://schemas.openxmlformats.org/drawingml/2006/main">
             <a:r>
-              <a:t>Скриншоты: работающий сайт https://85.8.201.148, 21.10.2026.</a:t>
+              <a:t>Скриншоты интерфейса и проверка VPS: 22.10.2026.</a:t>
             </a:r>
           </a:p>
           <a:p xmlns:a="http://schemas.openxmlformats.org/drawingml/2006/main">
             <a:r>
-              <a:t>Вклад: PR 21 и 31 Артёма, PR 32 и 34 Самира.</a:t>
+              <a:t>Первоначальные зоны ответственности: Самир — frontend и размещение, Артём — backend и БД. Интеграция совместная, фактические изменения сохранены в Git.</a:t>
             </a:r>
           </a:p>
           <a:p xmlns:a="http://schemas.openxmlformats.org/drawingml/2006/main">
@@ -556,37 +536,17 @@
           <a:lstStyle xmlns:a="http://schemas.openxmlformats.org/drawingml/2006/main"/>
           <a:p xmlns:a="http://schemas.openxmlformats.org/drawingml/2006/main">
             <a:r>
-              <a:t>Артём. Слайд 10.</a:t>
-            </a:r>
-          </a:p>
-          <a:p xmlns:a="http://schemas.openxmlformats.org/drawingml/2006/main">
-            <a:r>
-              <a:t/>
-            </a:r>
-          </a:p>
-          <a:p xmlns:a="http://schemas.openxmlformats.org/drawingml/2006/main">
-            <a:r>
-              <a:t>В полном прогоне прошли девяносто два серверных теста, пятьдесят тестов интерфейса и двадцать один браузерный сценарий с API. Покрытие строк сервисов составляет 97,3 процента при требовании 60. Проверяли роли, ошибки, выдачу и возврат, сохранение данных и экспорт. В результате получили работающее приложение с публичной ссылкой. Готовы показать его и ответить на вопросы.</a:t>
-            </a:r>
-          </a:p>
-          <a:p xmlns:a="http://schemas.openxmlformats.org/drawingml/2006/main">
-            <a:r>
-              <a:t/>
-            </a:r>
-          </a:p>
-          <a:p xmlns:a="http://schemas.openxmlformats.org/drawingml/2006/main">
-            <a:r>
               <a:t>Материалы проекта: https://github.com/Samirrrrr123/college-inventory</a:t>
             </a:r>
           </a:p>
           <a:p xmlns:a="http://schemas.openxmlformats.org/drawingml/2006/main">
             <a:r>
-              <a:t>Скриншоты: работающий сайт https://85.8.201.148, 21.10.2026.</a:t>
+              <a:t>Скриншоты интерфейса и проверка VPS: 22.10.2026.</a:t>
             </a:r>
           </a:p>
           <a:p xmlns:a="http://schemas.openxmlformats.org/drawingml/2006/main">
             <a:r>
-              <a:t>Вклад: PR 21 и 31 Артёма, PR 32 и 34 Самира.</a:t>
+              <a:t>Первоначальные зоны ответственности: Самир — frontend и размещение, Артём — backend и БД. Интеграция совместная, фактические изменения сохранены в Git.</a:t>
             </a:r>
           </a:p>
           <a:p xmlns:a="http://schemas.openxmlformats.org/drawingml/2006/main">
@@ -661,37 +621,17 @@
           <a:lstStyle xmlns:a="http://schemas.openxmlformats.org/drawingml/2006/main"/>
           <a:p xmlns:a="http://schemas.openxmlformats.org/drawingml/2006/main">
             <a:r>
-              <a:t>Самир. Слайд 2.</a:t>
-            </a:r>
-          </a:p>
-          <a:p xmlns:a="http://schemas.openxmlformats.org/drawingml/2006/main">
-            <a:r>
-              <a:t/>
-            </a:r>
-          </a:p>
-          <a:p xmlns:a="http://schemas.openxmlformats.org/drawingml/2006/main">
-            <a:r>
-              <a:t>У приложения три роли. Преподаватель ищет оборудование и отправляет заявку. Лаборант рассматривает заявки, выдаёт технику и принимает возвраты. Администратор управляет пользователями. Я занимался дизайном, основным интерфейсом и запуском, а также добавил часть серверных функций. Артём сделал API каталога и разделы истории. Подключение и проверки пересекались.</a:t>
-            </a:r>
-          </a:p>
-          <a:p xmlns:a="http://schemas.openxmlformats.org/drawingml/2006/main">
-            <a:r>
-              <a:t/>
-            </a:r>
-          </a:p>
-          <a:p xmlns:a="http://schemas.openxmlformats.org/drawingml/2006/main">
-            <a:r>
               <a:t>Материалы проекта: https://github.com/Samirrrrr123/college-inventory</a:t>
             </a:r>
           </a:p>
           <a:p xmlns:a="http://schemas.openxmlformats.org/drawingml/2006/main">
             <a:r>
-              <a:t>Скриншоты: работающий сайт https://85.8.201.148, 21.10.2026.</a:t>
+              <a:t>Скриншоты интерфейса и проверка VPS: 22.10.2026.</a:t>
             </a:r>
           </a:p>
           <a:p xmlns:a="http://schemas.openxmlformats.org/drawingml/2006/main">
             <a:r>
-              <a:t>Вклад: PR 21 и 31 Артёма, PR 32 и 34 Самира.</a:t>
+              <a:t>Первоначальные зоны ответственности: Самир — frontend и размещение, Артём — backend и БД. Интеграция совместная, фактические изменения сохранены в Git.</a:t>
             </a:r>
           </a:p>
           <a:p xmlns:a="http://schemas.openxmlformats.org/drawingml/2006/main">
@@ -766,37 +706,17 @@
           <a:lstStyle xmlns:a="http://schemas.openxmlformats.org/drawingml/2006/main"/>
           <a:p xmlns:a="http://schemas.openxmlformats.org/drawingml/2006/main">
             <a:r>
-              <a:t>Самир. Слайд 3.</a:t>
-            </a:r>
-          </a:p>
-          <a:p xmlns:a="http://schemas.openxmlformats.org/drawingml/2006/main">
-            <a:r>
-              <a:t/>
-            </a:r>
-          </a:p>
-          <a:p xmlns:a="http://schemas.openxmlformats.org/drawingml/2006/main">
-            <a:r>
-              <a:t>Перед вёрсткой подготовили шесть основных экранов в Figma. В интерфейсе одинаковые кнопки, поля и таблицы. Добавили состояния загрузки, ошибки и пустые списки. Сайт работает на телефоне и компьютере. Тему и язык можно переключать, а выбор сохраняется в браузере. Здесь показана мобильная версия работающего сайта.</a:t>
-            </a:r>
-          </a:p>
-          <a:p xmlns:a="http://schemas.openxmlformats.org/drawingml/2006/main">
-            <a:r>
-              <a:t/>
-            </a:r>
-          </a:p>
-          <a:p xmlns:a="http://schemas.openxmlformats.org/drawingml/2006/main">
-            <a:r>
               <a:t>Материалы проекта: https://github.com/Samirrrrr123/college-inventory</a:t>
             </a:r>
           </a:p>
           <a:p xmlns:a="http://schemas.openxmlformats.org/drawingml/2006/main">
             <a:r>
-              <a:t>Скриншоты: работающий сайт https://85.8.201.148, 21.10.2026.</a:t>
+              <a:t>Скриншоты интерфейса и проверка VPS: 22.10.2026.</a:t>
             </a:r>
           </a:p>
           <a:p xmlns:a="http://schemas.openxmlformats.org/drawingml/2006/main">
             <a:r>
-              <a:t>Вклад: PR 21 и 31 Артёма, PR 32 и 34 Самира.</a:t>
+              <a:t>Первоначальные зоны ответственности: Самир — frontend и размещение, Артём — backend и БД. Интеграция совместная, фактические изменения сохранены в Git.</a:t>
             </a:r>
           </a:p>
           <a:p xmlns:a="http://schemas.openxmlformats.org/drawingml/2006/main">
@@ -871,37 +791,17 @@
           <a:lstStyle xmlns:a="http://schemas.openxmlformats.org/drawingml/2006/main"/>
           <a:p xmlns:a="http://schemas.openxmlformats.org/drawingml/2006/main">
             <a:r>
-              <a:t>Самир. Слайд 4.</a:t>
-            </a:r>
-          </a:p>
-          <a:p xmlns:a="http://schemas.openxmlformats.org/drawingml/2006/main">
-            <a:r>
-              <a:t/>
-            </a:r>
-          </a:p>
-          <a:p xmlns:a="http://schemas.openxmlformats.org/drawingml/2006/main">
-            <a:r>
-              <a:t>Основной экран показывает каталог. Можно найти технику по названию, выбрать категорию или аудиторию. Поиск и деление на страницы выполняет сервер. Сотрудник добавляет и изменяет карточки, прикрепляет фотографию или PDF. Перед удалением появляется подтверждение. Экспорт скачивает весь найденный список с выбранными фильтрами, а не только текущую страницу.</a:t>
-            </a:r>
-          </a:p>
-          <a:p xmlns:a="http://schemas.openxmlformats.org/drawingml/2006/main">
-            <a:r>
-              <a:t/>
-            </a:r>
-          </a:p>
-          <a:p xmlns:a="http://schemas.openxmlformats.org/drawingml/2006/main">
-            <a:r>
               <a:t>Материалы проекта: https://github.com/Samirrrrr123/college-inventory</a:t>
             </a:r>
           </a:p>
           <a:p xmlns:a="http://schemas.openxmlformats.org/drawingml/2006/main">
             <a:r>
-              <a:t>Скриншоты: работающий сайт https://85.8.201.148, 21.10.2026.</a:t>
+              <a:t>Скриншоты интерфейса и проверка VPS: 22.10.2026.</a:t>
             </a:r>
           </a:p>
           <a:p xmlns:a="http://schemas.openxmlformats.org/drawingml/2006/main">
             <a:r>
-              <a:t>Вклад: PR 21 и 31 Артёма, PR 32 и 34 Самира.</a:t>
+              <a:t>Первоначальные зоны ответственности: Самир — frontend и размещение, Артём — backend и БД. Интеграция совместная, фактические изменения сохранены в Git.</a:t>
             </a:r>
           </a:p>
           <a:p xmlns:a="http://schemas.openxmlformats.org/drawingml/2006/main">
@@ -976,37 +876,17 @@
           <a:lstStyle xmlns:a="http://schemas.openxmlformats.org/drawingml/2006/main"/>
           <a:p xmlns:a="http://schemas.openxmlformats.org/drawingml/2006/main">
             <a:r>
-              <a:t>Самир. Слайд 5.</a:t>
-            </a:r>
-          </a:p>
-          <a:p xmlns:a="http://schemas.openxmlformats.org/drawingml/2006/main">
-            <a:r>
-              <a:t/>
-            </a:r>
-          </a:p>
-          <a:p xmlns:a="http://schemas.openxmlformats.org/drawingml/2006/main">
-            <a:r>
-              <a:t>Проект размещён на VPS в UFO Hosting. На нём работают интерфейс, API и PostgreSQL. Docker Compose запускает их вместе, а Caddy обеспечивает HTTPS. Сайт открывается по публичной ссылке. Перед обновлением сохраняем копию базы. GitHub Actions проверяет код, тесты и сборку. Дальше Артём расскажет, как устроена серверная часть.</a:t>
-            </a:r>
-          </a:p>
-          <a:p xmlns:a="http://schemas.openxmlformats.org/drawingml/2006/main">
-            <a:r>
-              <a:t/>
-            </a:r>
-          </a:p>
-          <a:p xmlns:a="http://schemas.openxmlformats.org/drawingml/2006/main">
-            <a:r>
               <a:t>Материалы проекта: https://github.com/Samirrrrr123/college-inventory</a:t>
             </a:r>
           </a:p>
           <a:p xmlns:a="http://schemas.openxmlformats.org/drawingml/2006/main">
             <a:r>
-              <a:t>Скриншоты: работающий сайт https://85.8.201.148, 21.10.2026.</a:t>
+              <a:t>Скриншоты интерфейса и проверка VPS: 22.10.2026.</a:t>
             </a:r>
           </a:p>
           <a:p xmlns:a="http://schemas.openxmlformats.org/drawingml/2006/main">
             <a:r>
-              <a:t>Вклад: PR 21 и 31 Артёма, PR 32 и 34 Самира.</a:t>
+              <a:t>Первоначальные зоны ответственности: Самир — frontend и размещение, Артём — backend и БД. Интеграция совместная, фактические изменения сохранены в Git.</a:t>
             </a:r>
           </a:p>
           <a:p xmlns:a="http://schemas.openxmlformats.org/drawingml/2006/main">
@@ -1081,37 +961,17 @@
           <a:lstStyle xmlns:a="http://schemas.openxmlformats.org/drawingml/2006/main"/>
           <a:p xmlns:a="http://schemas.openxmlformats.org/drawingml/2006/main">
             <a:r>
-              <a:t>Артём. Слайд 6.</a:t>
-            </a:r>
-          </a:p>
-          <a:p xmlns:a="http://schemas.openxmlformats.org/drawingml/2006/main">
-            <a:r>
-              <a:t/>
-            </a:r>
-          </a:p>
-          <a:p xmlns:a="http://schemas.openxmlformats.org/drawingml/2006/main">
-            <a:r>
-              <a:t>Интерфейс отправляет запросы в REST API на Express. Контроллер принимает запрос, сервис проверяет правила, а репозиторий работает с базой через Prisma. При входе сервер выдаёт access и refresh JWT. Пароли хранятся в виде bcrypt-хешей. Права проверяет сервер. Поэтому скрытой кнопки недостаточно, чужие данные защищены и при прямом запросе.</a:t>
-            </a:r>
-          </a:p>
-          <a:p xmlns:a="http://schemas.openxmlformats.org/drawingml/2006/main">
-            <a:r>
-              <a:t/>
-            </a:r>
-          </a:p>
-          <a:p xmlns:a="http://schemas.openxmlformats.org/drawingml/2006/main">
-            <a:r>
               <a:t>Материалы проекта: https://github.com/Samirrrrr123/college-inventory</a:t>
             </a:r>
           </a:p>
           <a:p xmlns:a="http://schemas.openxmlformats.org/drawingml/2006/main">
             <a:r>
-              <a:t>Скриншоты: работающий сайт https://85.8.201.148, 21.10.2026.</a:t>
+              <a:t>Скриншоты интерфейса и проверка VPS: 22.10.2026.</a:t>
             </a:r>
           </a:p>
           <a:p xmlns:a="http://schemas.openxmlformats.org/drawingml/2006/main">
             <a:r>
-              <a:t>Вклад: PR 21 и 31 Артёма, PR 32 и 34 Самира.</a:t>
+              <a:t>Первоначальные зоны ответственности: Самир — frontend и размещение, Артём — backend и БД. Интеграция совместная, фактические изменения сохранены в Git.</a:t>
             </a:r>
           </a:p>
           <a:p xmlns:a="http://schemas.openxmlformats.org/drawingml/2006/main">
@@ -1186,37 +1046,17 @@
           <a:lstStyle xmlns:a="http://schemas.openxmlformats.org/drawingml/2006/main"/>
           <a:p xmlns:a="http://schemas.openxmlformats.org/drawingml/2006/main">
             <a:r>
-              <a:t>Артём. Слайд 7.</a:t>
-            </a:r>
-          </a:p>
-          <a:p xmlns:a="http://schemas.openxmlformats.org/drawingml/2006/main">
-            <a:r>
-              <a:t/>
-            </a:r>
-          </a:p>
-          <a:p xmlns:a="http://schemas.openxmlformats.org/drawingml/2006/main">
-            <a:r>
-              <a:t>В PostgreSQL шестнадцать таблиц. Основные сущности: пользователь, роль, оборудование, категория, аудитория, заявка и выдача. Одна категория содержит много предметов. Заявка может включать несколько предметов, поэтому для состава есть отдельная таблица. Схема меняется через миграции. Тестовые данные добавляет seed. Моя часть включала каталог и связанные с ним таблицы.</a:t>
-            </a:r>
-          </a:p>
-          <a:p xmlns:a="http://schemas.openxmlformats.org/drawingml/2006/main">
-            <a:r>
-              <a:t/>
-            </a:r>
-          </a:p>
-          <a:p xmlns:a="http://schemas.openxmlformats.org/drawingml/2006/main">
-            <a:r>
               <a:t>Материалы проекта: https://github.com/Samirrrrr123/college-inventory</a:t>
             </a:r>
           </a:p>
           <a:p xmlns:a="http://schemas.openxmlformats.org/drawingml/2006/main">
             <a:r>
-              <a:t>Скриншоты: работающий сайт https://85.8.201.148, 21.10.2026.</a:t>
+              <a:t>Скриншоты интерфейса и проверка VPS: 22.10.2026.</a:t>
             </a:r>
           </a:p>
           <a:p xmlns:a="http://schemas.openxmlformats.org/drawingml/2006/main">
             <a:r>
-              <a:t>Вклад: PR 21 и 31 Артёма, PR 32 и 34 Самира.</a:t>
+              <a:t>Первоначальные зоны ответственности: Самир — frontend и размещение, Артём — backend и БД. Интеграция совместная, фактические изменения сохранены в Git.</a:t>
             </a:r>
           </a:p>
           <a:p xmlns:a="http://schemas.openxmlformats.org/drawingml/2006/main">
@@ -1291,37 +1131,17 @@
           <a:lstStyle xmlns:a="http://schemas.openxmlformats.org/drawingml/2006/main"/>
           <a:p xmlns:a="http://schemas.openxmlformats.org/drawingml/2006/main">
             <a:r>
-              <a:t>Артём. Слайд 8.</a:t>
-            </a:r>
-          </a:p>
-          <a:p xmlns:a="http://schemas.openxmlformats.org/drawingml/2006/main">
-            <a:r>
-              <a:t/>
-            </a:r>
-          </a:p>
-          <a:p xmlns:a="http://schemas.openxmlformats.org/drawingml/2006/main">
-            <a:r>
-              <a:t>Преподаватель отправляет заявку на один или несколько предметов. Лаборант одобряет или отклоняет её. Одобрение ещё не занимает технику. Доступность проверяется в момент выдачи. Весь комплект сохраняется одной операцией: если один предмет недоступен, выдача не создаётся. При возврате техника снова становится доступной. Эту часть API добавил Самир при интеграции.</a:t>
-            </a:r>
-          </a:p>
-          <a:p xmlns:a="http://schemas.openxmlformats.org/drawingml/2006/main">
-            <a:r>
-              <a:t/>
-            </a:r>
-          </a:p>
-          <a:p xmlns:a="http://schemas.openxmlformats.org/drawingml/2006/main">
-            <a:r>
               <a:t>Материалы проекта: https://github.com/Samirrrrr123/college-inventory</a:t>
             </a:r>
           </a:p>
           <a:p xmlns:a="http://schemas.openxmlformats.org/drawingml/2006/main">
             <a:r>
-              <a:t>Скриншоты: работающий сайт https://85.8.201.148, 21.10.2026.</a:t>
+              <a:t>Скриншоты интерфейса и проверка VPS: 22.10.2026.</a:t>
             </a:r>
           </a:p>
           <a:p xmlns:a="http://schemas.openxmlformats.org/drawingml/2006/main">
             <a:r>
-              <a:t>Вклад: PR 21 и 31 Артёма, PR 32 и 34 Самира.</a:t>
+              <a:t>Первоначальные зоны ответственности: Самир — frontend и размещение, Артём — backend и БД. Интеграция совместная, фактические изменения сохранены в Git.</a:t>
             </a:r>
           </a:p>
           <a:p xmlns:a="http://schemas.openxmlformats.org/drawingml/2006/main">
@@ -1396,37 +1216,17 @@
           <a:lstStyle xmlns:a="http://schemas.openxmlformats.org/drawingml/2006/main"/>
           <a:p xmlns:a="http://schemas.openxmlformats.org/drawingml/2006/main">
             <a:r>
-              <a:t>Артём. Слайд 9.</a:t>
-            </a:r>
-          </a:p>
-          <a:p xmlns:a="http://schemas.openxmlformats.org/drawingml/2006/main">
-            <a:r>
-              <a:t/>
-            </a:r>
-          </a:p>
-          <a:p xmlns:a="http://schemas.openxmlformats.org/drawingml/2006/main">
-            <a:r>
-              <a:t>В своей части я добавил перемещения и журнал аудита, включая API и экраны. Когда сотрудник меняет аудиторию предмета, в истории сохраняются старое и новое место, автор и дата. Администратор видит общий журнал действий. Для списков есть поиск, фильтры и страницы. Права доступа и поведение этих разделов проверены тестами.</a:t>
-            </a:r>
-          </a:p>
-          <a:p xmlns:a="http://schemas.openxmlformats.org/drawingml/2006/main">
-            <a:r>
-              <a:t/>
-            </a:r>
-          </a:p>
-          <a:p xmlns:a="http://schemas.openxmlformats.org/drawingml/2006/main">
-            <a:r>
               <a:t>Материалы проекта: https://github.com/Samirrrrr123/college-inventory</a:t>
             </a:r>
           </a:p>
           <a:p xmlns:a="http://schemas.openxmlformats.org/drawingml/2006/main">
             <a:r>
-              <a:t>Скриншоты: работающий сайт https://85.8.201.148, 21.10.2026.</a:t>
+              <a:t>Скриншоты интерфейса и проверка VPS: 22.10.2026.</a:t>
             </a:r>
           </a:p>
           <a:p xmlns:a="http://schemas.openxmlformats.org/drawingml/2006/main">
             <a:r>
-              <a:t>Вклад: PR 21 и 31 Артёма, PR 32 и 34 Самира.</a:t>
+              <a:t>Первоначальные зоны ответственности: Самир — frontend и размещение, Артём — backend и БД. Интеграция совместная, фактические изменения сохранены в Git.</a:t>
             </a:r>
           </a:p>
           <a:p xmlns:a="http://schemas.openxmlformats.org/drawingml/2006/main">
@@ -1478,7 +1278,7 @@
           <p:cNvPr id="3" name="Title">
             <a:extLst xmlns:a="http://schemas.openxmlformats.org/drawingml/2006/main">
               <a:ext uri="{FF2B5EF4-FFF2-40B4-BE49-F238E27FC236}">
-                <a16:creationId xmlns:a16="http://schemas.microsoft.com/office/drawing/2014/main" id="{6E087B5A-69C0-42F7-9C1D-E8B7297A9DA0}"/>
+                <a16:creationId xmlns:a16="http://schemas.microsoft.com/office/drawing/2014/main" id="{E516E3B5-7BDB-4336-880A-B39D75B377BC}"/>
               </a:ext>
             </a:extLst>
           </p:cNvPr>
@@ -1707,7 +1507,7 @@
           <p:cNvPr id="2" name="Subtitle">
             <a:extLst xmlns:a="http://schemas.openxmlformats.org/drawingml/2006/main">
               <a:ext uri="{FF2B5EF4-FFF2-40B4-BE49-F238E27FC236}">
-                <a16:creationId xmlns:a16="http://schemas.microsoft.com/office/drawing/2014/main" id="{B028732E-EDB6-4478-BF48-CE52B4882FB3}"/>
+                <a16:creationId xmlns:a16="http://schemas.microsoft.com/office/drawing/2014/main" id="{6E726BE8-42B9-429D-B405-657DE2197808}"/>
               </a:ext>
             </a:extLst>
           </p:cNvPr>
@@ -1953,7 +1753,7 @@
           <p:cNvPr id="2" name="Section title">
             <a:extLst xmlns:a="http://schemas.openxmlformats.org/drawingml/2006/main">
               <a:ext uri="{FF2B5EF4-FFF2-40B4-BE49-F238E27FC236}">
-                <a16:creationId xmlns:a16="http://schemas.microsoft.com/office/drawing/2014/main" id="{2FFABF69-D859-469A-8F09-675DDE4D29F0}"/>
+                <a16:creationId xmlns:a16="http://schemas.microsoft.com/office/drawing/2014/main" id="{99154102-CC34-4746-8FBB-4F92219E7927}"/>
               </a:ext>
             </a:extLst>
           </p:cNvPr>
@@ -2199,7 +1999,7 @@
           <p:cNvPr id="3" name="Title">
             <a:extLst xmlns:a="http://schemas.openxmlformats.org/drawingml/2006/main">
               <a:ext uri="{FF2B5EF4-FFF2-40B4-BE49-F238E27FC236}">
-                <a16:creationId xmlns:a16="http://schemas.microsoft.com/office/drawing/2014/main" id="{1A7EB47F-86A0-4C60-AE3F-8A7377112D02}"/>
+                <a16:creationId xmlns:a16="http://schemas.microsoft.com/office/drawing/2014/main" id="{DB7C8771-40D3-41CD-AAB5-82C5F5E348EA}"/>
               </a:ext>
             </a:extLst>
           </p:cNvPr>
@@ -2428,7 +2228,7 @@
           <p:cNvPr id="2" name="Body">
             <a:extLst xmlns:a="http://schemas.openxmlformats.org/drawingml/2006/main">
               <a:ext uri="{FF2B5EF4-FFF2-40B4-BE49-F238E27FC236}">
-                <a16:creationId xmlns:a16="http://schemas.microsoft.com/office/drawing/2014/main" id="{02BFA598-5E74-4BA2-A0A6-88F3EA9AB23D}"/>
+                <a16:creationId xmlns:a16="http://schemas.microsoft.com/office/drawing/2014/main" id="{B33609E2-1F1E-429E-AA82-49FB55E809FD}"/>
               </a:ext>
             </a:extLst>
           </p:cNvPr>
@@ -2674,7 +2474,7 @@
           <p:cNvPr id="4" name="Title">
             <a:extLst xmlns:a="http://schemas.openxmlformats.org/drawingml/2006/main">
               <a:ext uri="{FF2B5EF4-FFF2-40B4-BE49-F238E27FC236}">
-                <a16:creationId xmlns:a16="http://schemas.microsoft.com/office/drawing/2014/main" id="{E5AD50AE-216E-43D2-BE6B-4198D6F043A7}"/>
+                <a16:creationId xmlns:a16="http://schemas.microsoft.com/office/drawing/2014/main" id="{5CF17303-AF8B-4033-95C4-C0B36A81716B}"/>
               </a:ext>
             </a:extLst>
           </p:cNvPr>
@@ -2903,7 +2703,7 @@
           <p:cNvPr id="2" name="Left column">
             <a:extLst xmlns:a="http://schemas.openxmlformats.org/drawingml/2006/main">
               <a:ext uri="{FF2B5EF4-FFF2-40B4-BE49-F238E27FC236}">
-                <a16:creationId xmlns:a16="http://schemas.microsoft.com/office/drawing/2014/main" id="{207CF366-D2F6-4328-87E5-D578D2017A8F}"/>
+                <a16:creationId xmlns:a16="http://schemas.microsoft.com/office/drawing/2014/main" id="{38D66F79-43B0-4EA7-B461-39D5BEB21547}"/>
               </a:ext>
             </a:extLst>
           </p:cNvPr>
@@ -3132,7 +2932,7 @@
           <p:cNvPr id="3" name="Right column">
             <a:extLst xmlns:a="http://schemas.openxmlformats.org/drawingml/2006/main">
               <a:ext uri="{FF2B5EF4-FFF2-40B4-BE49-F238E27FC236}">
-                <a16:creationId xmlns:a16="http://schemas.microsoft.com/office/drawing/2014/main" id="{FEC6BC74-5212-402A-8DCB-448D71E92D71}"/>
+                <a16:creationId xmlns:a16="http://schemas.microsoft.com/office/drawing/2014/main" id="{4B9E4031-7EBD-4E0E-A917-3AC002015194}"/>
               </a:ext>
             </a:extLst>
           </p:cNvPr>
@@ -3378,7 +3178,7 @@
           <p:cNvPr id="3" name="Title">
             <a:extLst xmlns:a="http://schemas.openxmlformats.org/drawingml/2006/main">
               <a:ext uri="{FF2B5EF4-FFF2-40B4-BE49-F238E27FC236}">
-                <a16:creationId xmlns:a16="http://schemas.microsoft.com/office/drawing/2014/main" id="{EA719378-E778-4AC6-9DC0-4DCE9F4DDE93}"/>
+                <a16:creationId xmlns:a16="http://schemas.microsoft.com/office/drawing/2014/main" id="{41CD51F2-982C-487D-AAA5-4959B56FB19B}"/>
               </a:ext>
             </a:extLst>
           </p:cNvPr>
@@ -3607,7 +3407,7 @@
           <p:cNvPr id="2" name="Left column">
             <a:extLst xmlns:a="http://schemas.openxmlformats.org/drawingml/2006/main">
               <a:ext uri="{FF2B5EF4-FFF2-40B4-BE49-F238E27FC236}">
-                <a16:creationId xmlns:a16="http://schemas.microsoft.com/office/drawing/2014/main" id="{62252C5B-DD6D-4A85-92A7-AFCAC5A1DAAD}"/>
+                <a16:creationId xmlns:a16="http://schemas.microsoft.com/office/drawing/2014/main" id="{7ED73F9B-0126-4EF1-8D78-915DA796C248}"/>
               </a:ext>
             </a:extLst>
           </p:cNvPr>
@@ -3874,12 +3674,12 @@
   </p:cSld>
   <p:clrMap bg1="lt1" tx1="dk1" bg2="lt2" tx2="dk2" accent1="accent1" accent2="accent2" accent3="accent3" accent4="accent4" accent5="accent5" accent6="accent6" hlink="hlink" folHlink="folHlink"/>
   <p:sldLayoutIdLst>
-    <p:sldLayoutId xmlns:r="http://schemas.openxmlformats.org/officeDocument/2006/relationships" id="2147483649" r:id="R6d6033dddc5f4d8e"/>
-    <p:sldLayoutId xmlns:r="http://schemas.openxmlformats.org/officeDocument/2006/relationships" id="2147483650" r:id="R1db138bdc2614230"/>
-    <p:sldLayoutId xmlns:r="http://schemas.openxmlformats.org/officeDocument/2006/relationships" id="2147483651" r:id="R79966f58f9c64752"/>
-    <p:sldLayoutId xmlns:r="http://schemas.openxmlformats.org/officeDocument/2006/relationships" id="2147483652" r:id="Rec5fb0b02eeb4355"/>
-    <p:sldLayoutId xmlns:r="http://schemas.openxmlformats.org/officeDocument/2006/relationships" id="2147483653" r:id="R56a8a43c7ddd439d"/>
-    <p:sldLayoutId xmlns:r="http://schemas.openxmlformats.org/officeDocument/2006/relationships" id="2147483654" r:id="R6cbbe705f3274d83"/>
+    <p:sldLayoutId xmlns:r="http://schemas.openxmlformats.org/officeDocument/2006/relationships" id="2147483649" r:id="R8aa71702010341e6"/>
+    <p:sldLayoutId xmlns:r="http://schemas.openxmlformats.org/officeDocument/2006/relationships" id="2147483650" r:id="Rf07e659285fb45d8"/>
+    <p:sldLayoutId xmlns:r="http://schemas.openxmlformats.org/officeDocument/2006/relationships" id="2147483651" r:id="R1811e3a9a26f4ddb"/>
+    <p:sldLayoutId xmlns:r="http://schemas.openxmlformats.org/officeDocument/2006/relationships" id="2147483652" r:id="R4efb014ec8154442"/>
+    <p:sldLayoutId xmlns:r="http://schemas.openxmlformats.org/officeDocument/2006/relationships" id="2147483653" r:id="R925477ae893c4f51"/>
+    <p:sldLayoutId xmlns:r="http://schemas.openxmlformats.org/officeDocument/2006/relationships" id="2147483654" r:id="R56a422d651ae4978"/>
   </p:sldLayoutIdLst>
   <p:txStyles>
     <p:titleStyle>
@@ -4430,7 +4230,7 @@
           <p:cNvPr id="4" name="">
             <a:extLst xmlns:a="http://schemas.openxmlformats.org/drawingml/2006/main">
               <a:ext uri="{FF2B5EF4-FFF2-40B4-BE49-F238E27FC236}">
-                <a16:creationId xmlns:a16="http://schemas.microsoft.com/office/drawing/2014/main" id="{B54F82F1-EB5F-4CE5-97A9-222B8168B8C8}"/>
+                <a16:creationId xmlns:a16="http://schemas.microsoft.com/office/drawing/2014/main" id="{CD7C41F0-B85C-4A6E-8D6B-51DEEE9B93F1}"/>
               </a:ext>
             </a:extLst>
           </p:cNvPr>
@@ -4588,7 +4388,7 @@
           <p:cNvPr id="2" name="">
             <a:extLst xmlns:a="http://schemas.openxmlformats.org/drawingml/2006/main">
               <a:ext uri="{FF2B5EF4-FFF2-40B4-BE49-F238E27FC236}">
-                <a16:creationId xmlns:a16="http://schemas.microsoft.com/office/drawing/2014/main" id="{DE54D126-2F48-4E6E-AAB4-3791BB8E69A6}"/>
+                <a16:creationId xmlns:a16="http://schemas.microsoft.com/office/drawing/2014/main" id="{6A8DFE38-B0C5-4DA0-9196-4FB6180C9E42}"/>
               </a:ext>
             </a:extLst>
           </p:cNvPr>
@@ -4736,7 +4536,7 @@
                 <a:ea typeface="Arial"/>
                 <a:cs typeface="Arial"/>
               </a:rPr>
-              <a:t>Учебная практика</a:t>
+              <a:t>IThub, группа 4p1.23</a:t>
             </a:r>
           </a:p>
           <a:p xmlns:a="http://schemas.openxmlformats.org/drawingml/2006/main">
@@ -4759,7 +4559,7 @@
                 <a:ea typeface="Arial"/>
                 <a:cs typeface="Arial"/>
               </a:rPr>
-              <a:t>Командный проект Самира и Артёма</a:t>
+              <a:t>Ясинов Самир Парвизович</a:t>
             </a:r>
           </a:p>
           <a:p xmlns:a="http://schemas.openxmlformats.org/drawingml/2006/main">
@@ -4782,7 +4582,7 @@
                 <a:ea typeface="Arial"/>
                 <a:cs typeface="Arial"/>
               </a:rPr>
-              <a:t>Приложение «Инвентарь»</a:t>
+              <a:t>Николаиди Артём Георгиевич</a:t>
             </a:r>
           </a:p>
         </p:txBody>
@@ -4792,7 +4592,7 @@
           <p:cNvPr id="3" name="">
             <a:extLst xmlns:a="http://schemas.openxmlformats.org/drawingml/2006/main">
               <a:ext uri="{FF2B5EF4-FFF2-40B4-BE49-F238E27FC236}">
-                <a16:creationId xmlns:a16="http://schemas.microsoft.com/office/drawing/2014/main" id="{8BF88333-6FE0-45A9-A7F3-4BABABBCF117}"/>
+                <a16:creationId xmlns:a16="http://schemas.microsoft.com/office/drawing/2014/main" id="{E3639866-2A80-4C72-981A-4D173D90916C}"/>
               </a:ext>
             </a:extLst>
           </p:cNvPr>
@@ -4948,7 +4748,7 @@
     </p:spTree>
     <p:extLst>
       <p:ext uri="{BB962C8B-B14F-4D97-AF65-F5344CB8AC3E}">
-        <p14:creationId xmlns:p14="http://schemas.microsoft.com/office/powerpoint/2010/main" val="1997619342"/>
+        <p14:creationId xmlns:p14="http://schemas.microsoft.com/office/powerpoint/2010/main" val="1528758542"/>
       </p:ext>
     </p:extLst>
   </p:cSld>
@@ -4979,7 +4779,7 @@
           <p:cNvPr id="6" name="">
             <a:extLst xmlns:a="http://schemas.openxmlformats.org/drawingml/2006/main">
               <a:ext uri="{FF2B5EF4-FFF2-40B4-BE49-F238E27FC236}">
-                <a16:creationId xmlns:a16="http://schemas.microsoft.com/office/drawing/2014/main" id="{C1838069-D326-4D7F-BA47-EBEA43FD63F2}"/>
+                <a16:creationId xmlns:a16="http://schemas.microsoft.com/office/drawing/2014/main" id="{B278BF10-9D9A-4C87-AF9B-68909B7E2891}"/>
               </a:ext>
             </a:extLst>
           </p:cNvPr>
@@ -5137,7 +4937,7 @@
           <p:cNvPr id="2" name="">
             <a:extLst xmlns:a="http://schemas.openxmlformats.org/drawingml/2006/main">
               <a:ext uri="{FF2B5EF4-FFF2-40B4-BE49-F238E27FC236}">
-                <a16:creationId xmlns:a16="http://schemas.microsoft.com/office/drawing/2014/main" id="{009099B6-2D4D-4672-A4A5-88A5476F4CF4}"/>
+                <a16:creationId xmlns:a16="http://schemas.microsoft.com/office/drawing/2014/main" id="{0F7786C0-9884-4170-8255-4819D2AA4CE1}"/>
               </a:ext>
             </a:extLst>
           </p:cNvPr>
@@ -5577,7 +5377,7 @@
           <p:cNvPr id="3" name="">
             <a:extLst xmlns:a="http://schemas.openxmlformats.org/drawingml/2006/main">
               <a:ext uri="{FF2B5EF4-FFF2-40B4-BE49-F238E27FC236}">
-                <a16:creationId xmlns:a16="http://schemas.microsoft.com/office/drawing/2014/main" id="{B06F9DC7-373F-4280-9939-B2D86E2C5584}"/>
+                <a16:creationId xmlns:a16="http://schemas.microsoft.com/office/drawing/2014/main" id="{B01657C5-A956-451C-B21A-6A9051387C69}"/>
               </a:ext>
             </a:extLst>
           </p:cNvPr>
@@ -5735,7 +5535,7 @@
                 <a:latin typeface="Arial"/>
                 <a:ea typeface="Arial"/>
                 <a:cs typeface="Arial"/>
-                <a:hlinkClick xmlns:r="http://schemas.openxmlformats.org/officeDocument/2006/relationships" r:id="R4d19baa92cbc43c8"/>
+                <a:hlinkClick xmlns:r="http://schemas.openxmlformats.org/officeDocument/2006/relationships" r:id="R2aa8d27ac5e546f7"/>
               </a:rPr>
               <a:t>https://85.8.201.148/login</a:t>
             </a:r>
@@ -5747,7 +5547,7 @@
           <p:cNvPr id="4" name="">
             <a:extLst xmlns:a="http://schemas.openxmlformats.org/drawingml/2006/main">
               <a:ext uri="{FF2B5EF4-FFF2-40B4-BE49-F238E27FC236}">
-                <a16:creationId xmlns:a16="http://schemas.microsoft.com/office/drawing/2014/main" id="{E7A3C302-8B6A-471D-82F2-D78AA7F6CDE9}"/>
+                <a16:creationId xmlns:a16="http://schemas.microsoft.com/office/drawing/2014/main" id="{1694EAC1-3AE2-4613-AC87-7BCE68666223}"/>
               </a:ext>
             </a:extLst>
           </p:cNvPr>
@@ -5905,7 +5705,7 @@
                 <a:latin typeface="Arial"/>
                 <a:ea typeface="Arial"/>
                 <a:cs typeface="Arial"/>
-                <a:hlinkClick xmlns:r="http://schemas.openxmlformats.org/officeDocument/2006/relationships" r:id="Ra4834a30df324976"/>
+                <a:hlinkClick xmlns:r="http://schemas.openxmlformats.org/officeDocument/2006/relationships" r:id="R362bad722c624b0e"/>
               </a:rPr>
               <a:t>Samirrrrr123/college-inventory</a:t>
             </a:r>
@@ -5917,7 +5717,7 @@
           <p:cNvPr id="5" name="">
             <a:extLst xmlns:a="http://schemas.openxmlformats.org/drawingml/2006/main">
               <a:ext uri="{FF2B5EF4-FFF2-40B4-BE49-F238E27FC236}">
-                <a16:creationId xmlns:a16="http://schemas.microsoft.com/office/drawing/2014/main" id="{B83F12D7-CDA0-4BFF-8F6B-FD4D88DFC821}"/>
+                <a16:creationId xmlns:a16="http://schemas.microsoft.com/office/drawing/2014/main" id="{7526572E-85CA-4284-B9F5-E62C24E0A97D}"/>
               </a:ext>
             </a:extLst>
           </p:cNvPr>
@@ -6073,7 +5873,7 @@
     </p:spTree>
     <p:extLst>
       <p:ext uri="{BB962C8B-B14F-4D97-AF65-F5344CB8AC3E}">
-        <p14:creationId xmlns:p14="http://schemas.microsoft.com/office/powerpoint/2010/main" val="242331181"/>
+        <p14:creationId xmlns:p14="http://schemas.microsoft.com/office/powerpoint/2010/main" val="1718393992"/>
       </p:ext>
     </p:extLst>
   </p:cSld>
@@ -6104,7 +5904,7 @@
           <p:cNvPr id="10" name="">
             <a:extLst xmlns:a="http://schemas.openxmlformats.org/drawingml/2006/main">
               <a:ext uri="{FF2B5EF4-FFF2-40B4-BE49-F238E27FC236}">
-                <a16:creationId xmlns:a16="http://schemas.microsoft.com/office/drawing/2014/main" id="{07F07486-D749-4AA9-98AD-7B31F4497EDD}"/>
+                <a16:creationId xmlns:a16="http://schemas.microsoft.com/office/drawing/2014/main" id="{9F28A3BC-C94E-477F-8C43-254B4B54C407}"/>
               </a:ext>
             </a:extLst>
           </p:cNvPr>
@@ -6262,7 +6062,7 @@
           <p:cNvPr id="2" name="">
             <a:extLst xmlns:a="http://schemas.openxmlformats.org/drawingml/2006/main">
               <a:ext uri="{FF2B5EF4-FFF2-40B4-BE49-F238E27FC236}">
-                <a16:creationId xmlns:a16="http://schemas.microsoft.com/office/drawing/2014/main" id="{6FC0DCED-577F-4094-9672-5728672E181F}"/>
+                <a16:creationId xmlns:a16="http://schemas.microsoft.com/office/drawing/2014/main" id="{C38543F8-A221-417F-AB03-D6DE69A741BE}"/>
               </a:ext>
             </a:extLst>
           </p:cNvPr>
@@ -6274,7 +6074,7 @@
         <p:spPr>
           <a:xfrm xmlns:a="http://schemas.openxmlformats.org/drawingml/2006/main">
             <a:off x="685800" y="1562100"/>
-            <a:ext cx="4048125" cy="647700"/>
+            <a:ext cx="3381375" cy="647700"/>
           </a:xfrm>
           <a:prstGeom xmlns:a="http://schemas.openxmlformats.org/drawingml/2006/main" prst="rect">
             <a:avLst/>
@@ -6420,7 +6220,7 @@
           <p:cNvPr id="3" name="">
             <a:extLst xmlns:a="http://schemas.openxmlformats.org/drawingml/2006/main">
               <a:ext uri="{FF2B5EF4-FFF2-40B4-BE49-F238E27FC236}">
-                <a16:creationId xmlns:a16="http://schemas.microsoft.com/office/drawing/2014/main" id="{EC754E24-AB42-4836-9D12-517AD8486194}"/>
+                <a16:creationId xmlns:a16="http://schemas.microsoft.com/office/drawing/2014/main" id="{2F9F203C-1E54-4A0B-A167-64361E26146E}"/>
               </a:ext>
             </a:extLst>
           </p:cNvPr>
@@ -6432,7 +6232,7 @@
         <p:spPr>
           <a:xfrm xmlns:a="http://schemas.openxmlformats.org/drawingml/2006/main">
             <a:off x="685800" y="2286000"/>
-            <a:ext cx="4048125" cy="647700"/>
+            <a:ext cx="3381375" cy="647700"/>
           </a:xfrm>
           <a:prstGeom xmlns:a="http://schemas.openxmlformats.org/drawingml/2006/main" prst="rect">
             <a:avLst/>
@@ -6578,7 +6378,7 @@
           <p:cNvPr id="4" name="">
             <a:extLst xmlns:a="http://schemas.openxmlformats.org/drawingml/2006/main">
               <a:ext uri="{FF2B5EF4-FFF2-40B4-BE49-F238E27FC236}">
-                <a16:creationId xmlns:a16="http://schemas.microsoft.com/office/drawing/2014/main" id="{9467E02E-6C3A-47C0-8518-A591CDDBBD55}"/>
+                <a16:creationId xmlns:a16="http://schemas.microsoft.com/office/drawing/2014/main" id="{565C8BD2-077E-4022-B4C7-854216A8A002}"/>
               </a:ext>
             </a:extLst>
           </p:cNvPr>
@@ -6590,7 +6390,7 @@
         <p:spPr>
           <a:xfrm xmlns:a="http://schemas.openxmlformats.org/drawingml/2006/main">
             <a:off x="685800" y="3009900"/>
-            <a:ext cx="4048125" cy="647700"/>
+            <a:ext cx="3381375" cy="647700"/>
           </a:xfrm>
           <a:prstGeom xmlns:a="http://schemas.openxmlformats.org/drawingml/2006/main" prst="rect">
             <a:avLst/>
@@ -6736,7 +6536,7 @@
           <p:cNvPr id="5" name="">
             <a:extLst xmlns:a="http://schemas.openxmlformats.org/drawingml/2006/main">
               <a:ext uri="{FF2B5EF4-FFF2-40B4-BE49-F238E27FC236}">
-                <a16:creationId xmlns:a16="http://schemas.microsoft.com/office/drawing/2014/main" id="{356CBB64-8C72-4A8B-A160-91DFAA6544E6}"/>
+                <a16:creationId xmlns:a16="http://schemas.microsoft.com/office/drawing/2014/main" id="{7E77F6F7-951A-4C1A-A1BB-F7D193719788}"/>
               </a:ext>
             </a:extLst>
           </p:cNvPr>
@@ -6748,7 +6548,7 @@
         <p:spPr>
           <a:xfrm xmlns:a="http://schemas.openxmlformats.org/drawingml/2006/main">
             <a:off x="685800" y="3733800"/>
-            <a:ext cx="4048125" cy="647700"/>
+            <a:ext cx="3381375" cy="647700"/>
           </a:xfrm>
           <a:prstGeom xmlns:a="http://schemas.openxmlformats.org/drawingml/2006/main" prst="rect">
             <a:avLst/>
@@ -6884,7 +6684,7 @@
                 <a:ea typeface="Arial"/>
                 <a:cs typeface="Arial"/>
               </a:rPr>
-              <a:t>Самир: интерфейс и запуск</a:t>
+              <a:t>План: Самир — frontend и запуск</a:t>
             </a:r>
           </a:p>
         </p:txBody>
@@ -6894,7 +6694,7 @@
           <p:cNvPr id="6" name="">
             <a:extLst xmlns:a="http://schemas.openxmlformats.org/drawingml/2006/main">
               <a:ext uri="{FF2B5EF4-FFF2-40B4-BE49-F238E27FC236}">
-                <a16:creationId xmlns:a16="http://schemas.microsoft.com/office/drawing/2014/main" id="{E6A18E64-F228-40DB-B2A2-342EB2E538F1}"/>
+                <a16:creationId xmlns:a16="http://schemas.microsoft.com/office/drawing/2014/main" id="{FA673B39-019C-4C9F-9C43-B1906A44E834}"/>
               </a:ext>
             </a:extLst>
           </p:cNvPr>
@@ -6906,7 +6706,7 @@
         <p:spPr>
           <a:xfrm xmlns:a="http://schemas.openxmlformats.org/drawingml/2006/main">
             <a:off x="685800" y="4457700"/>
-            <a:ext cx="4048125" cy="647700"/>
+            <a:ext cx="3381375" cy="647700"/>
           </a:xfrm>
           <a:prstGeom xmlns:a="http://schemas.openxmlformats.org/drawingml/2006/main" prst="rect">
             <a:avLst/>
@@ -7042,7 +6842,7 @@
                 <a:ea typeface="Arial"/>
                 <a:cs typeface="Arial"/>
               </a:rPr>
-              <a:t>Артём: каталог API и история</a:t>
+              <a:t>План: Артём — backend и БД</a:t>
             </a:r>
           </a:p>
         </p:txBody>
@@ -7052,7 +6852,7 @@
           <p:cNvPr id="7" name="">
             <a:extLst xmlns:a="http://schemas.openxmlformats.org/drawingml/2006/main">
               <a:ext uri="{FF2B5EF4-FFF2-40B4-BE49-F238E27FC236}">
-                <a16:creationId xmlns:a16="http://schemas.microsoft.com/office/drawing/2014/main" id="{82CDE4BF-CEFB-4F2A-8123-E4032C3306B2}"/>
+                <a16:creationId xmlns:a16="http://schemas.microsoft.com/office/drawing/2014/main" id="{4172B422-2608-444B-8C20-8C4854D54CB7}"/>
               </a:ext>
             </a:extLst>
           </p:cNvPr>
@@ -7064,7 +6864,7 @@
         <p:spPr>
           <a:xfrm xmlns:a="http://schemas.openxmlformats.org/drawingml/2006/main">
             <a:off x="685800" y="5181600"/>
-            <a:ext cx="4048125" cy="647700"/>
+            <a:ext cx="3381375" cy="647700"/>
           </a:xfrm>
           <a:prstGeom xmlns:a="http://schemas.openxmlformats.org/drawingml/2006/main" prst="rect">
             <a:avLst/>
@@ -7200,7 +7000,7 @@
                 <a:ea typeface="Arial"/>
                 <a:cs typeface="Arial"/>
               </a:rPr>
-              <a:t>Подключение и проверки выполняли вместе</a:t>
+              <a:t>Совместная интеграция и проверки</a:t>
             </a:r>
           </a:p>
         </p:txBody>
@@ -7210,7 +7010,7 @@
           <p:cNvPr id="8" name="">
             <a:extLst xmlns:a="http://schemas.openxmlformats.org/drawingml/2006/main">
               <a:ext uri="{FF2B5EF4-FFF2-40B4-BE49-F238E27FC236}">
-                <a16:creationId xmlns:a16="http://schemas.microsoft.com/office/drawing/2014/main" id="{CB934D8C-A847-419C-B86A-0719E03752F4}"/>
+                <a16:creationId xmlns:a16="http://schemas.microsoft.com/office/drawing/2014/main" id="{A9A3432E-69B8-4F5B-8F95-05DE988F0D2C}"/>
               </a:ext>
             </a:extLst>
           </p:cNvPr>
@@ -7220,13 +7020,13 @@
           <p:nvPr/>
         </p:nvPicPr>
         <p:blipFill>
-          <a:blip xmlns:r="http://schemas.openxmlformats.org/officeDocument/2006/relationships" xmlns:a="http://schemas.openxmlformats.org/drawingml/2006/main" r:embed="Ra55af77b7b734a9f"/>
+          <a:blip xmlns:r="http://schemas.openxmlformats.org/officeDocument/2006/relationships" xmlns:a="http://schemas.openxmlformats.org/drawingml/2006/main" r:embed="R845049199d894512"/>
           <a:stretch xmlns:a="http://schemas.openxmlformats.org/drawingml/2006/main"/>
         </p:blipFill>
         <p:spPr>
           <a:xfrm xmlns:a="http://schemas.openxmlformats.org/drawingml/2006/main">
-            <a:off x="5049393" y="1438275"/>
-            <a:ext cx="6569964" cy="4562475"/>
+            <a:off x="4429125" y="1810477"/>
+            <a:ext cx="7143750" cy="3999046"/>
           </a:xfrm>
           <a:prstGeom xmlns:a="http://schemas.openxmlformats.org/drawingml/2006/main" prst="rect">
             <a:avLst/>
@@ -7238,7 +7038,7 @@
           <p:cNvPr id="9" name="">
             <a:extLst xmlns:a="http://schemas.openxmlformats.org/drawingml/2006/main">
               <a:ext uri="{FF2B5EF4-FFF2-40B4-BE49-F238E27FC236}">
-                <a16:creationId xmlns:a16="http://schemas.microsoft.com/office/drawing/2014/main" id="{0BF33A5A-813E-4CB7-81B9-D8C3B8868BDA}"/>
+                <a16:creationId xmlns:a16="http://schemas.microsoft.com/office/drawing/2014/main" id="{E304FCE3-1D38-45EB-AF23-8AF640545BD9}"/>
               </a:ext>
             </a:extLst>
           </p:cNvPr>
@@ -7394,7 +7194,7 @@
     </p:spTree>
     <p:extLst>
       <p:ext uri="{BB962C8B-B14F-4D97-AF65-F5344CB8AC3E}">
-        <p14:creationId xmlns:p14="http://schemas.microsoft.com/office/powerpoint/2010/main" val="861748204"/>
+        <p14:creationId xmlns:p14="http://schemas.microsoft.com/office/powerpoint/2010/main" val="1447162737"/>
       </p:ext>
     </p:extLst>
   </p:cSld>
@@ -7425,7 +7225,7 @@
           <p:cNvPr id="8" name="">
             <a:extLst xmlns:a="http://schemas.openxmlformats.org/drawingml/2006/main">
               <a:ext uri="{FF2B5EF4-FFF2-40B4-BE49-F238E27FC236}">
-                <a16:creationId xmlns:a16="http://schemas.microsoft.com/office/drawing/2014/main" id="{643E1EDD-23AF-4CD7-8476-562FA39F301E}"/>
+                <a16:creationId xmlns:a16="http://schemas.microsoft.com/office/drawing/2014/main" id="{02B69F5A-66DC-43CE-AFC3-665BC24B1C17}"/>
               </a:ext>
             </a:extLst>
           </p:cNvPr>
@@ -7583,7 +7383,7 @@
           <p:cNvPr id="2" name="">
             <a:extLst xmlns:a="http://schemas.openxmlformats.org/drawingml/2006/main">
               <a:ext uri="{FF2B5EF4-FFF2-40B4-BE49-F238E27FC236}">
-                <a16:creationId xmlns:a16="http://schemas.microsoft.com/office/drawing/2014/main" id="{8B4358CA-B95F-4827-9F77-E425EA7532DB}"/>
+                <a16:creationId xmlns:a16="http://schemas.microsoft.com/office/drawing/2014/main" id="{E0D0B33A-460D-48AB-B70E-C716A87AA40C}"/>
               </a:ext>
             </a:extLst>
           </p:cNvPr>
@@ -7595,7 +7395,7 @@
         <p:spPr>
           <a:xfrm xmlns:a="http://schemas.openxmlformats.org/drawingml/2006/main">
             <a:off x="685800" y="1562100"/>
-            <a:ext cx="4048125" cy="647700"/>
+            <a:ext cx="3381375" cy="647700"/>
           </a:xfrm>
           <a:prstGeom xmlns:a="http://schemas.openxmlformats.org/drawingml/2006/main" prst="rect">
             <a:avLst/>
@@ -7741,7 +7541,7 @@
           <p:cNvPr id="3" name="">
             <a:extLst xmlns:a="http://schemas.openxmlformats.org/drawingml/2006/main">
               <a:ext uri="{FF2B5EF4-FFF2-40B4-BE49-F238E27FC236}">
-                <a16:creationId xmlns:a16="http://schemas.microsoft.com/office/drawing/2014/main" id="{DDD76739-E4E5-4BC3-9C76-4F16DBA9D6E1}"/>
+                <a16:creationId xmlns:a16="http://schemas.microsoft.com/office/drawing/2014/main" id="{9DD9BFB6-385C-4AFE-9F66-3AD74C8EFB96}"/>
               </a:ext>
             </a:extLst>
           </p:cNvPr>
@@ -7753,7 +7553,7 @@
         <p:spPr>
           <a:xfrm xmlns:a="http://schemas.openxmlformats.org/drawingml/2006/main">
             <a:off x="685800" y="2362200"/>
-            <a:ext cx="4048125" cy="647700"/>
+            <a:ext cx="3381375" cy="647700"/>
           </a:xfrm>
           <a:prstGeom xmlns:a="http://schemas.openxmlformats.org/drawingml/2006/main" prst="rect">
             <a:avLst/>
@@ -7899,7 +7699,7 @@
           <p:cNvPr id="4" name="">
             <a:extLst xmlns:a="http://schemas.openxmlformats.org/drawingml/2006/main">
               <a:ext uri="{FF2B5EF4-FFF2-40B4-BE49-F238E27FC236}">
-                <a16:creationId xmlns:a16="http://schemas.microsoft.com/office/drawing/2014/main" id="{28882E07-CA21-4740-A80E-6AD123E56A38}"/>
+                <a16:creationId xmlns:a16="http://schemas.microsoft.com/office/drawing/2014/main" id="{BC6E0DFC-EB7B-4BBD-BEEC-30F7E164DD22}"/>
               </a:ext>
             </a:extLst>
           </p:cNvPr>
@@ -7911,7 +7711,7 @@
         <p:spPr>
           <a:xfrm xmlns:a="http://schemas.openxmlformats.org/drawingml/2006/main">
             <a:off x="685800" y="3162300"/>
-            <a:ext cx="4048125" cy="647700"/>
+            <a:ext cx="3381375" cy="647700"/>
           </a:xfrm>
           <a:prstGeom xmlns:a="http://schemas.openxmlformats.org/drawingml/2006/main" prst="rect">
             <a:avLst/>
@@ -8057,7 +7857,7 @@
           <p:cNvPr id="5" name="">
             <a:extLst xmlns:a="http://schemas.openxmlformats.org/drawingml/2006/main">
               <a:ext uri="{FF2B5EF4-FFF2-40B4-BE49-F238E27FC236}">
-                <a16:creationId xmlns:a16="http://schemas.microsoft.com/office/drawing/2014/main" id="{779BDAC7-5587-461F-B492-648982268E8A}"/>
+                <a16:creationId xmlns:a16="http://schemas.microsoft.com/office/drawing/2014/main" id="{DA03BA44-6AF1-49DC-803D-3A8875F1DD99}"/>
               </a:ext>
             </a:extLst>
           </p:cNvPr>
@@ -8069,7 +7869,7 @@
         <p:spPr>
           <a:xfrm xmlns:a="http://schemas.openxmlformats.org/drawingml/2006/main">
             <a:off x="685800" y="3962400"/>
-            <a:ext cx="4048125" cy="647700"/>
+            <a:ext cx="3381375" cy="647700"/>
           </a:xfrm>
           <a:prstGeom xmlns:a="http://schemas.openxmlformats.org/drawingml/2006/main" prst="rect">
             <a:avLst/>
@@ -8215,7 +8015,7 @@
           <p:cNvPr id="6" name="">
             <a:extLst xmlns:a="http://schemas.openxmlformats.org/drawingml/2006/main">
               <a:ext uri="{FF2B5EF4-FFF2-40B4-BE49-F238E27FC236}">
-                <a16:creationId xmlns:a16="http://schemas.microsoft.com/office/drawing/2014/main" id="{C373524D-45D3-4E92-98F7-11DBD61257EE}"/>
+                <a16:creationId xmlns:a16="http://schemas.microsoft.com/office/drawing/2014/main" id="{A2908381-BA3C-40F0-911B-C6AA1A310B85}"/>
               </a:ext>
             </a:extLst>
           </p:cNvPr>
@@ -8225,13 +8025,13 @@
           <p:nvPr/>
         </p:nvPicPr>
         <p:blipFill>
-          <a:blip xmlns:r="http://schemas.openxmlformats.org/officeDocument/2006/relationships" xmlns:a="http://schemas.openxmlformats.org/drawingml/2006/main" r:embed="Rfd815d5887644a46"/>
+          <a:blip xmlns:r="http://schemas.openxmlformats.org/officeDocument/2006/relationships" xmlns:a="http://schemas.openxmlformats.org/drawingml/2006/main" r:embed="R2c159c15f1394109"/>
           <a:stretch xmlns:a="http://schemas.openxmlformats.org/drawingml/2006/main"/>
         </p:blipFill>
         <p:spPr>
           <a:xfrm xmlns:a="http://schemas.openxmlformats.org/drawingml/2006/main">
-            <a:off x="7715250" y="1287951"/>
-            <a:ext cx="2238375" cy="4844073"/>
+            <a:off x="6096000" y="1476375"/>
+            <a:ext cx="3714750" cy="4572000"/>
           </a:xfrm>
           <a:prstGeom xmlns:a="http://schemas.openxmlformats.org/drawingml/2006/main" prst="rect">
             <a:avLst/>
@@ -8243,7 +8043,7 @@
           <p:cNvPr id="7" name="">
             <a:extLst xmlns:a="http://schemas.openxmlformats.org/drawingml/2006/main">
               <a:ext uri="{FF2B5EF4-FFF2-40B4-BE49-F238E27FC236}">
-                <a16:creationId xmlns:a16="http://schemas.microsoft.com/office/drawing/2014/main" id="{70059AEF-8C69-44B5-A8A9-0FDD01A6FEB7}"/>
+                <a16:creationId xmlns:a16="http://schemas.microsoft.com/office/drawing/2014/main" id="{52422E19-B88D-4C41-806F-3402EBA46AB3}"/>
               </a:ext>
             </a:extLst>
           </p:cNvPr>
@@ -8399,7 +8199,7 @@
     </p:spTree>
     <p:extLst>
       <p:ext uri="{BB962C8B-B14F-4D97-AF65-F5344CB8AC3E}">
-        <p14:creationId xmlns:p14="http://schemas.microsoft.com/office/powerpoint/2010/main" val="1223145240"/>
+        <p14:creationId xmlns:p14="http://schemas.microsoft.com/office/powerpoint/2010/main" val="265888516"/>
       </p:ext>
     </p:extLst>
   </p:cSld>
@@ -8430,7 +8230,7 @@
           <p:cNvPr id="9" name="">
             <a:extLst xmlns:a="http://schemas.openxmlformats.org/drawingml/2006/main">
               <a:ext uri="{FF2B5EF4-FFF2-40B4-BE49-F238E27FC236}">
-                <a16:creationId xmlns:a16="http://schemas.microsoft.com/office/drawing/2014/main" id="{3D8E116C-2F84-4AD8-872B-7C50064C105C}"/>
+                <a16:creationId xmlns:a16="http://schemas.microsoft.com/office/drawing/2014/main" id="{DA68C30F-2E05-4009-9C49-8EA5D1D9244A}"/>
               </a:ext>
             </a:extLst>
           </p:cNvPr>
@@ -8588,7 +8388,7 @@
           <p:cNvPr id="2" name="">
             <a:extLst xmlns:a="http://schemas.openxmlformats.org/drawingml/2006/main">
               <a:ext uri="{FF2B5EF4-FFF2-40B4-BE49-F238E27FC236}">
-                <a16:creationId xmlns:a16="http://schemas.microsoft.com/office/drawing/2014/main" id="{610B9CB2-5296-4C7F-B994-2BC847D7A12D}"/>
+                <a16:creationId xmlns:a16="http://schemas.microsoft.com/office/drawing/2014/main" id="{AFA5F96A-A86C-427E-B724-59E3828A5924}"/>
               </a:ext>
             </a:extLst>
           </p:cNvPr>
@@ -8600,7 +8400,7 @@
         <p:spPr>
           <a:xfrm xmlns:a="http://schemas.openxmlformats.org/drawingml/2006/main">
             <a:off x="685800" y="1562100"/>
-            <a:ext cx="4048125" cy="647700"/>
+            <a:ext cx="3381375" cy="647700"/>
           </a:xfrm>
           <a:prstGeom xmlns:a="http://schemas.openxmlformats.org/drawingml/2006/main" prst="rect">
             <a:avLst/>
@@ -8746,7 +8546,7 @@
           <p:cNvPr id="3" name="">
             <a:extLst xmlns:a="http://schemas.openxmlformats.org/drawingml/2006/main">
               <a:ext uri="{FF2B5EF4-FFF2-40B4-BE49-F238E27FC236}">
-                <a16:creationId xmlns:a16="http://schemas.microsoft.com/office/drawing/2014/main" id="{47F02D91-76A8-4A1E-991E-4907971B8B1A}"/>
+                <a16:creationId xmlns:a16="http://schemas.microsoft.com/office/drawing/2014/main" id="{30933E52-0FAB-48A7-BCC1-A4B963B600B8}"/>
               </a:ext>
             </a:extLst>
           </p:cNvPr>
@@ -8758,7 +8558,7 @@
         <p:spPr>
           <a:xfrm xmlns:a="http://schemas.openxmlformats.org/drawingml/2006/main">
             <a:off x="685800" y="2362200"/>
-            <a:ext cx="4048125" cy="647700"/>
+            <a:ext cx="3381375" cy="647700"/>
           </a:xfrm>
           <a:prstGeom xmlns:a="http://schemas.openxmlformats.org/drawingml/2006/main" prst="rect">
             <a:avLst/>
@@ -8904,7 +8704,7 @@
           <p:cNvPr id="4" name="">
             <a:extLst xmlns:a="http://schemas.openxmlformats.org/drawingml/2006/main">
               <a:ext uri="{FF2B5EF4-FFF2-40B4-BE49-F238E27FC236}">
-                <a16:creationId xmlns:a16="http://schemas.microsoft.com/office/drawing/2014/main" id="{2EA79ABC-E284-44B4-A099-8807242791F5}"/>
+                <a16:creationId xmlns:a16="http://schemas.microsoft.com/office/drawing/2014/main" id="{E140073A-3945-4A3B-B6CC-6294BB97CEF7}"/>
               </a:ext>
             </a:extLst>
           </p:cNvPr>
@@ -8916,7 +8716,7 @@
         <p:spPr>
           <a:xfrm xmlns:a="http://schemas.openxmlformats.org/drawingml/2006/main">
             <a:off x="685800" y="3162300"/>
-            <a:ext cx="4048125" cy="647700"/>
+            <a:ext cx="3381375" cy="647700"/>
           </a:xfrm>
           <a:prstGeom xmlns:a="http://schemas.openxmlformats.org/drawingml/2006/main" prst="rect">
             <a:avLst/>
@@ -9062,7 +8862,7 @@
           <p:cNvPr id="5" name="">
             <a:extLst xmlns:a="http://schemas.openxmlformats.org/drawingml/2006/main">
               <a:ext uri="{FF2B5EF4-FFF2-40B4-BE49-F238E27FC236}">
-                <a16:creationId xmlns:a16="http://schemas.microsoft.com/office/drawing/2014/main" id="{38C667D6-9A9A-42C0-B703-727413825DB8}"/>
+                <a16:creationId xmlns:a16="http://schemas.microsoft.com/office/drawing/2014/main" id="{EC0D04D0-F467-462A-A7CD-5E9D176DA7B0}"/>
               </a:ext>
             </a:extLst>
           </p:cNvPr>
@@ -9074,7 +8874,7 @@
         <p:spPr>
           <a:xfrm xmlns:a="http://schemas.openxmlformats.org/drawingml/2006/main">
             <a:off x="685800" y="3962400"/>
-            <a:ext cx="4048125" cy="647700"/>
+            <a:ext cx="3381375" cy="647700"/>
           </a:xfrm>
           <a:prstGeom xmlns:a="http://schemas.openxmlformats.org/drawingml/2006/main" prst="rect">
             <a:avLst/>
@@ -9220,7 +9020,7 @@
           <p:cNvPr id="6" name="">
             <a:extLst xmlns:a="http://schemas.openxmlformats.org/drawingml/2006/main">
               <a:ext uri="{FF2B5EF4-FFF2-40B4-BE49-F238E27FC236}">
-                <a16:creationId xmlns:a16="http://schemas.microsoft.com/office/drawing/2014/main" id="{135EBA24-C065-4ED8-801A-8BCC343DBD9E}"/>
+                <a16:creationId xmlns:a16="http://schemas.microsoft.com/office/drawing/2014/main" id="{3D80DA38-B5BA-42C5-A4F5-AE3582858518}"/>
               </a:ext>
             </a:extLst>
           </p:cNvPr>
@@ -9232,7 +9032,7 @@
         <p:spPr>
           <a:xfrm xmlns:a="http://schemas.openxmlformats.org/drawingml/2006/main">
             <a:off x="685800" y="4762500"/>
-            <a:ext cx="4048125" cy="647700"/>
+            <a:ext cx="3381375" cy="647700"/>
           </a:xfrm>
           <a:prstGeom xmlns:a="http://schemas.openxmlformats.org/drawingml/2006/main" prst="rect">
             <a:avLst/>
@@ -9378,7 +9178,7 @@
           <p:cNvPr id="7" name="">
             <a:extLst xmlns:a="http://schemas.openxmlformats.org/drawingml/2006/main">
               <a:ext uri="{FF2B5EF4-FFF2-40B4-BE49-F238E27FC236}">
-                <a16:creationId xmlns:a16="http://schemas.microsoft.com/office/drawing/2014/main" id="{BC26549A-3CB2-42F4-A970-2E354D6ED08B}"/>
+                <a16:creationId xmlns:a16="http://schemas.microsoft.com/office/drawing/2014/main" id="{1EA7327A-3FF0-4F52-9816-F0D301B47B01}"/>
               </a:ext>
             </a:extLst>
           </p:cNvPr>
@@ -9388,13 +9188,13 @@
           <p:nvPr/>
         </p:nvPicPr>
         <p:blipFill>
-          <a:blip xmlns:r="http://schemas.openxmlformats.org/officeDocument/2006/relationships" xmlns:a="http://schemas.openxmlformats.org/drawingml/2006/main" r:embed="R139e01e89e3a4036"/>
+          <a:blip xmlns:r="http://schemas.openxmlformats.org/officeDocument/2006/relationships" xmlns:a="http://schemas.openxmlformats.org/drawingml/2006/main" r:embed="Rad361146c22240e0"/>
           <a:stretch xmlns:a="http://schemas.openxmlformats.org/drawingml/2006/main"/>
         </p:blipFill>
         <p:spPr>
           <a:xfrm xmlns:a="http://schemas.openxmlformats.org/drawingml/2006/main">
-            <a:off x="5049393" y="1438275"/>
-            <a:ext cx="6569964" cy="4562475"/>
+            <a:off x="4429125" y="1829137"/>
+            <a:ext cx="7143750" cy="3961726"/>
           </a:xfrm>
           <a:prstGeom xmlns:a="http://schemas.openxmlformats.org/drawingml/2006/main" prst="rect">
             <a:avLst/>
@@ -9406,7 +9206,7 @@
           <p:cNvPr id="8" name="">
             <a:extLst xmlns:a="http://schemas.openxmlformats.org/drawingml/2006/main">
               <a:ext uri="{FF2B5EF4-FFF2-40B4-BE49-F238E27FC236}">
-                <a16:creationId xmlns:a16="http://schemas.microsoft.com/office/drawing/2014/main" id="{16EFE2D8-D131-4BE5-ADAC-3051F7004E39}"/>
+                <a16:creationId xmlns:a16="http://schemas.microsoft.com/office/drawing/2014/main" id="{6DF3992E-0616-4A73-B5D6-21A51E6B997D}"/>
               </a:ext>
             </a:extLst>
           </p:cNvPr>
@@ -9562,7 +9362,7 @@
     </p:spTree>
     <p:extLst>
       <p:ext uri="{BB962C8B-B14F-4D97-AF65-F5344CB8AC3E}">
-        <p14:creationId xmlns:p14="http://schemas.microsoft.com/office/powerpoint/2010/main" val="1556531790"/>
+        <p14:creationId xmlns:p14="http://schemas.microsoft.com/office/powerpoint/2010/main" val="1725996414"/>
       </p:ext>
     </p:extLst>
   </p:cSld>
@@ -9593,7 +9393,7 @@
           <p:cNvPr id="9" name="">
             <a:extLst xmlns:a="http://schemas.openxmlformats.org/drawingml/2006/main">
               <a:ext uri="{FF2B5EF4-FFF2-40B4-BE49-F238E27FC236}">
-                <a16:creationId xmlns:a16="http://schemas.microsoft.com/office/drawing/2014/main" id="{641FFF16-FBCA-4B0B-BB60-9AE8525682A3}"/>
+                <a16:creationId xmlns:a16="http://schemas.microsoft.com/office/drawing/2014/main" id="{5AEC6E90-0333-43ED-B1E4-7A1FCA12F38B}"/>
               </a:ext>
             </a:extLst>
           </p:cNvPr>
@@ -9751,7 +9551,7 @@
           <p:cNvPr id="2" name="">
             <a:extLst xmlns:a="http://schemas.openxmlformats.org/drawingml/2006/main">
               <a:ext uri="{FF2B5EF4-FFF2-40B4-BE49-F238E27FC236}">
-                <a16:creationId xmlns:a16="http://schemas.microsoft.com/office/drawing/2014/main" id="{6E91EA2A-12F4-4550-9D33-D0D171E1275A}"/>
+                <a16:creationId xmlns:a16="http://schemas.microsoft.com/office/drawing/2014/main" id="{1CFF079E-1B4C-4CCC-9E33-87DDB93C8ED0}"/>
               </a:ext>
             </a:extLst>
           </p:cNvPr>
@@ -9763,7 +9563,7 @@
         <p:spPr>
           <a:xfrm xmlns:a="http://schemas.openxmlformats.org/drawingml/2006/main">
             <a:off x="685800" y="1562100"/>
-            <a:ext cx="4048125" cy="647700"/>
+            <a:ext cx="3381375" cy="647700"/>
           </a:xfrm>
           <a:prstGeom xmlns:a="http://schemas.openxmlformats.org/drawingml/2006/main" prst="rect">
             <a:avLst/>
@@ -9909,7 +9709,7 @@
           <p:cNvPr id="3" name="">
             <a:extLst xmlns:a="http://schemas.openxmlformats.org/drawingml/2006/main">
               <a:ext uri="{FF2B5EF4-FFF2-40B4-BE49-F238E27FC236}">
-                <a16:creationId xmlns:a16="http://schemas.microsoft.com/office/drawing/2014/main" id="{9BA0F3B8-B26C-454D-99A1-70204B485A81}"/>
+                <a16:creationId xmlns:a16="http://schemas.microsoft.com/office/drawing/2014/main" id="{46845810-DD1A-49BB-9F77-7B3498C50BC3}"/>
               </a:ext>
             </a:extLst>
           </p:cNvPr>
@@ -9921,7 +9721,7 @@
         <p:spPr>
           <a:xfrm xmlns:a="http://schemas.openxmlformats.org/drawingml/2006/main">
             <a:off x="685800" y="2362200"/>
-            <a:ext cx="4048125" cy="647700"/>
+            <a:ext cx="3381375" cy="647700"/>
           </a:xfrm>
           <a:prstGeom xmlns:a="http://schemas.openxmlformats.org/drawingml/2006/main" prst="rect">
             <a:avLst/>
@@ -10067,7 +9867,7 @@
           <p:cNvPr id="4" name="">
             <a:extLst xmlns:a="http://schemas.openxmlformats.org/drawingml/2006/main">
               <a:ext uri="{FF2B5EF4-FFF2-40B4-BE49-F238E27FC236}">
-                <a16:creationId xmlns:a16="http://schemas.microsoft.com/office/drawing/2014/main" id="{9676F94E-165F-44BE-9EBF-E1A326A92E71}"/>
+                <a16:creationId xmlns:a16="http://schemas.microsoft.com/office/drawing/2014/main" id="{D8385162-7A50-44C3-B3B0-C3DC0993B135}"/>
               </a:ext>
             </a:extLst>
           </p:cNvPr>
@@ -10079,7 +9879,7 @@
         <p:spPr>
           <a:xfrm xmlns:a="http://schemas.openxmlformats.org/drawingml/2006/main">
             <a:off x="685800" y="3162300"/>
-            <a:ext cx="4048125" cy="647700"/>
+            <a:ext cx="3381375" cy="647700"/>
           </a:xfrm>
           <a:prstGeom xmlns:a="http://schemas.openxmlformats.org/drawingml/2006/main" prst="rect">
             <a:avLst/>
@@ -10225,7 +10025,7 @@
           <p:cNvPr id="5" name="">
             <a:extLst xmlns:a="http://schemas.openxmlformats.org/drawingml/2006/main">
               <a:ext uri="{FF2B5EF4-FFF2-40B4-BE49-F238E27FC236}">
-                <a16:creationId xmlns:a16="http://schemas.microsoft.com/office/drawing/2014/main" id="{BEEB78A7-8FAD-443C-9FDA-E43697C60244}"/>
+                <a16:creationId xmlns:a16="http://schemas.microsoft.com/office/drawing/2014/main" id="{DB57463F-6E8B-40F3-B089-801F37DA32D0}"/>
               </a:ext>
             </a:extLst>
           </p:cNvPr>
@@ -10237,7 +10037,7 @@
         <p:spPr>
           <a:xfrm xmlns:a="http://schemas.openxmlformats.org/drawingml/2006/main">
             <a:off x="685800" y="3962400"/>
-            <a:ext cx="4048125" cy="647700"/>
+            <a:ext cx="3381375" cy="647700"/>
           </a:xfrm>
           <a:prstGeom xmlns:a="http://schemas.openxmlformats.org/drawingml/2006/main" prst="rect">
             <a:avLst/>
@@ -10383,7 +10183,7 @@
           <p:cNvPr id="6" name="">
             <a:extLst xmlns:a="http://schemas.openxmlformats.org/drawingml/2006/main">
               <a:ext uri="{FF2B5EF4-FFF2-40B4-BE49-F238E27FC236}">
-                <a16:creationId xmlns:a16="http://schemas.microsoft.com/office/drawing/2014/main" id="{85BED08F-7C13-43C7-88BB-F278F5427CBC}"/>
+                <a16:creationId xmlns:a16="http://schemas.microsoft.com/office/drawing/2014/main" id="{F3F22FC5-F5A6-4D90-BE12-F9A878215507}"/>
               </a:ext>
             </a:extLst>
           </p:cNvPr>
@@ -10395,7 +10195,7 @@
         <p:spPr>
           <a:xfrm xmlns:a="http://schemas.openxmlformats.org/drawingml/2006/main">
             <a:off x="685800" y="4762500"/>
-            <a:ext cx="4048125" cy="647700"/>
+            <a:ext cx="3381375" cy="647700"/>
           </a:xfrm>
           <a:prstGeom xmlns:a="http://schemas.openxmlformats.org/drawingml/2006/main" prst="rect">
             <a:avLst/>
@@ -10541,7 +10341,7 @@
           <p:cNvPr id="7" name="">
             <a:extLst xmlns:a="http://schemas.openxmlformats.org/drawingml/2006/main">
               <a:ext uri="{FF2B5EF4-FFF2-40B4-BE49-F238E27FC236}">
-                <a16:creationId xmlns:a16="http://schemas.microsoft.com/office/drawing/2014/main" id="{7E445CB5-E5B8-48BD-A065-ED01961C0EE0}"/>
+                <a16:creationId xmlns:a16="http://schemas.microsoft.com/office/drawing/2014/main" id="{40AB9246-D5EB-4110-8FE4-BADDAE49B2C1}"/>
               </a:ext>
             </a:extLst>
           </p:cNvPr>
@@ -10551,13 +10351,13 @@
           <p:nvPr/>
         </p:nvPicPr>
         <p:blipFill>
-          <a:blip xmlns:r="http://schemas.openxmlformats.org/officeDocument/2006/relationships" xmlns:a="http://schemas.openxmlformats.org/drawingml/2006/main" r:embed="R677ab835283e4fbb"/>
+          <a:blip xmlns:r="http://schemas.openxmlformats.org/officeDocument/2006/relationships" xmlns:a="http://schemas.openxmlformats.org/drawingml/2006/main" r:embed="Rd75f1d9acf09438b"/>
           <a:stretch xmlns:a="http://schemas.openxmlformats.org/drawingml/2006/main"/>
         </p:blipFill>
         <p:spPr>
           <a:xfrm xmlns:a="http://schemas.openxmlformats.org/drawingml/2006/main">
-            <a:off x="5049393" y="1438275"/>
-            <a:ext cx="6569964" cy="4562475"/>
+            <a:off x="4429125" y="1454082"/>
+            <a:ext cx="7143750" cy="4711835"/>
           </a:xfrm>
           <a:prstGeom xmlns:a="http://schemas.openxmlformats.org/drawingml/2006/main" prst="rect">
             <a:avLst/>
@@ -10569,7 +10369,7 @@
           <p:cNvPr id="8" name="">
             <a:extLst xmlns:a="http://schemas.openxmlformats.org/drawingml/2006/main">
               <a:ext uri="{FF2B5EF4-FFF2-40B4-BE49-F238E27FC236}">
-                <a16:creationId xmlns:a16="http://schemas.microsoft.com/office/drawing/2014/main" id="{1BEACD7E-20A8-4C9E-AC15-EAC24331756C}"/>
+                <a16:creationId xmlns:a16="http://schemas.microsoft.com/office/drawing/2014/main" id="{032F8637-083B-4203-9E86-9DD6944C4301}"/>
               </a:ext>
             </a:extLst>
           </p:cNvPr>
@@ -10725,7 +10525,7 @@
     </p:spTree>
     <p:extLst>
       <p:ext uri="{BB962C8B-B14F-4D97-AF65-F5344CB8AC3E}">
-        <p14:creationId xmlns:p14="http://schemas.microsoft.com/office/powerpoint/2010/main" val="236678964"/>
+        <p14:creationId xmlns:p14="http://schemas.microsoft.com/office/powerpoint/2010/main" val="326611188"/>
       </p:ext>
     </p:extLst>
   </p:cSld>
@@ -10756,7 +10556,7 @@
           <p:cNvPr id="8" name="">
             <a:extLst xmlns:a="http://schemas.openxmlformats.org/drawingml/2006/main">
               <a:ext uri="{FF2B5EF4-FFF2-40B4-BE49-F238E27FC236}">
-                <a16:creationId xmlns:a16="http://schemas.microsoft.com/office/drawing/2014/main" id="{CF7678E3-8987-4970-964C-019E94995BB7}"/>
+                <a16:creationId xmlns:a16="http://schemas.microsoft.com/office/drawing/2014/main" id="{C8300118-E816-434F-B07E-6A2315AC83FD}"/>
               </a:ext>
             </a:extLst>
           </p:cNvPr>
@@ -10914,7 +10714,7 @@
           <p:cNvPr id="2" name="">
             <a:extLst xmlns:a="http://schemas.openxmlformats.org/drawingml/2006/main">
               <a:ext uri="{FF2B5EF4-FFF2-40B4-BE49-F238E27FC236}">
-                <a16:creationId xmlns:a16="http://schemas.microsoft.com/office/drawing/2014/main" id="{F53ED70D-BE34-44D3-B5BB-20369698C4B5}"/>
+                <a16:creationId xmlns:a16="http://schemas.microsoft.com/office/drawing/2014/main" id="{A4E6A55D-B877-4142-943E-EBB66468D263}"/>
               </a:ext>
             </a:extLst>
           </p:cNvPr>
@@ -11072,7 +10872,7 @@
           <p:cNvPr id="3" name="">
             <a:extLst xmlns:a="http://schemas.openxmlformats.org/drawingml/2006/main">
               <a:ext uri="{FF2B5EF4-FFF2-40B4-BE49-F238E27FC236}">
-                <a16:creationId xmlns:a16="http://schemas.microsoft.com/office/drawing/2014/main" id="{19365760-D4D0-48AB-A281-44D4311F1A7F}"/>
+                <a16:creationId xmlns:a16="http://schemas.microsoft.com/office/drawing/2014/main" id="{F5E27744-D079-48BF-BF0D-37BE4AFDDEA4}"/>
               </a:ext>
             </a:extLst>
           </p:cNvPr>
@@ -11230,7 +11030,7 @@
           <p:cNvPr id="4" name="">
             <a:extLst xmlns:a="http://schemas.openxmlformats.org/drawingml/2006/main">
               <a:ext uri="{FF2B5EF4-FFF2-40B4-BE49-F238E27FC236}">
-                <a16:creationId xmlns:a16="http://schemas.microsoft.com/office/drawing/2014/main" id="{84CE49C6-C6F7-49F0-A3BD-1B47FC302EDE}"/>
+                <a16:creationId xmlns:a16="http://schemas.microsoft.com/office/drawing/2014/main" id="{E2A91193-3F71-4FD1-9F73-991ED9C25187}"/>
               </a:ext>
             </a:extLst>
           </p:cNvPr>
@@ -11388,7 +11188,7 @@
           <p:cNvPr id="5" name="">
             <a:extLst xmlns:a="http://schemas.openxmlformats.org/drawingml/2006/main">
               <a:ext uri="{FF2B5EF4-FFF2-40B4-BE49-F238E27FC236}">
-                <a16:creationId xmlns:a16="http://schemas.microsoft.com/office/drawing/2014/main" id="{30E744DE-356B-412E-AC27-2056C22FB875}"/>
+                <a16:creationId xmlns:a16="http://schemas.microsoft.com/office/drawing/2014/main" id="{1F92F1E8-C07E-4124-AB4E-004F7FC8B4C0}"/>
               </a:ext>
             </a:extLst>
           </p:cNvPr>
@@ -11546,7 +11346,7 @@
           <p:cNvPr id="6" name="">
             <a:extLst xmlns:a="http://schemas.openxmlformats.org/drawingml/2006/main">
               <a:ext uri="{FF2B5EF4-FFF2-40B4-BE49-F238E27FC236}">
-                <a16:creationId xmlns:a16="http://schemas.microsoft.com/office/drawing/2014/main" id="{005FFB7B-BD2B-4FE9-986F-1701679E88FB}"/>
+                <a16:creationId xmlns:a16="http://schemas.microsoft.com/office/drawing/2014/main" id="{81D3F78C-804C-4A46-985E-9D4CD2775D76}"/>
               </a:ext>
             </a:extLst>
           </p:cNvPr>
@@ -11704,7 +11504,7 @@
           <p:cNvPr id="7" name="">
             <a:extLst xmlns:a="http://schemas.openxmlformats.org/drawingml/2006/main">
               <a:ext uri="{FF2B5EF4-FFF2-40B4-BE49-F238E27FC236}">
-                <a16:creationId xmlns:a16="http://schemas.microsoft.com/office/drawing/2014/main" id="{461F21C2-1BF6-4D97-AE18-4404CE64BD54}"/>
+                <a16:creationId xmlns:a16="http://schemas.microsoft.com/office/drawing/2014/main" id="{ACE23093-C557-48D0-AABD-6A37E3369756}"/>
               </a:ext>
             </a:extLst>
           </p:cNvPr>
@@ -11860,7 +11660,7 @@
     </p:spTree>
     <p:extLst>
       <p:ext uri="{BB962C8B-B14F-4D97-AF65-F5344CB8AC3E}">
-        <p14:creationId xmlns:p14="http://schemas.microsoft.com/office/powerpoint/2010/main" val="1540564753"/>
+        <p14:creationId xmlns:p14="http://schemas.microsoft.com/office/powerpoint/2010/main" val="417213402"/>
       </p:ext>
     </p:extLst>
   </p:cSld>
@@ -11891,7 +11691,7 @@
           <p:cNvPr id="9" name="">
             <a:extLst xmlns:a="http://schemas.openxmlformats.org/drawingml/2006/main">
               <a:ext uri="{FF2B5EF4-FFF2-40B4-BE49-F238E27FC236}">
-                <a16:creationId xmlns:a16="http://schemas.microsoft.com/office/drawing/2014/main" id="{063DD45B-8777-4148-BD63-F30E37806D78}"/>
+                <a16:creationId xmlns:a16="http://schemas.microsoft.com/office/drawing/2014/main" id="{D5F125D5-617A-4984-99B2-EB9ECD4AFABC}"/>
               </a:ext>
             </a:extLst>
           </p:cNvPr>
@@ -12049,7 +11849,7 @@
           <p:cNvPr id="2" name="">
             <a:extLst xmlns:a="http://schemas.openxmlformats.org/drawingml/2006/main">
               <a:ext uri="{FF2B5EF4-FFF2-40B4-BE49-F238E27FC236}">
-                <a16:creationId xmlns:a16="http://schemas.microsoft.com/office/drawing/2014/main" id="{7459FCE9-D61D-4BED-BFFD-DB1B24E9C1A5}"/>
+                <a16:creationId xmlns:a16="http://schemas.microsoft.com/office/drawing/2014/main" id="{7B7F51CE-56CD-45A4-B43E-9DDCFEB12238}"/>
               </a:ext>
             </a:extLst>
           </p:cNvPr>
@@ -12061,7 +11861,7 @@
         <p:spPr>
           <a:xfrm xmlns:a="http://schemas.openxmlformats.org/drawingml/2006/main">
             <a:off x="685800" y="1562100"/>
-            <a:ext cx="4048125" cy="647700"/>
+            <a:ext cx="3381375" cy="647700"/>
           </a:xfrm>
           <a:prstGeom xmlns:a="http://schemas.openxmlformats.org/drawingml/2006/main" prst="rect">
             <a:avLst/>
@@ -12207,7 +12007,7 @@
           <p:cNvPr id="3" name="">
             <a:extLst xmlns:a="http://schemas.openxmlformats.org/drawingml/2006/main">
               <a:ext uri="{FF2B5EF4-FFF2-40B4-BE49-F238E27FC236}">
-                <a16:creationId xmlns:a16="http://schemas.microsoft.com/office/drawing/2014/main" id="{0A2CD4F4-2FCE-421A-950B-50D6C89C3D7A}"/>
+                <a16:creationId xmlns:a16="http://schemas.microsoft.com/office/drawing/2014/main" id="{757C7524-04B4-4EA7-BE85-F37068AA9260}"/>
               </a:ext>
             </a:extLst>
           </p:cNvPr>
@@ -12219,7 +12019,7 @@
         <p:spPr>
           <a:xfrm xmlns:a="http://schemas.openxmlformats.org/drawingml/2006/main">
             <a:off x="685800" y="2362200"/>
-            <a:ext cx="4048125" cy="647700"/>
+            <a:ext cx="3381375" cy="647700"/>
           </a:xfrm>
           <a:prstGeom xmlns:a="http://schemas.openxmlformats.org/drawingml/2006/main" prst="rect">
             <a:avLst/>
@@ -12365,7 +12165,7 @@
           <p:cNvPr id="4" name="">
             <a:extLst xmlns:a="http://schemas.openxmlformats.org/drawingml/2006/main">
               <a:ext uri="{FF2B5EF4-FFF2-40B4-BE49-F238E27FC236}">
-                <a16:creationId xmlns:a16="http://schemas.microsoft.com/office/drawing/2014/main" id="{E76FE256-3971-4DF6-B26A-2FCBB3CBA52D}"/>
+                <a16:creationId xmlns:a16="http://schemas.microsoft.com/office/drawing/2014/main" id="{070B42D0-C9FE-4E03-B800-86056653FA64}"/>
               </a:ext>
             </a:extLst>
           </p:cNvPr>
@@ -12377,7 +12177,7 @@
         <p:spPr>
           <a:xfrm xmlns:a="http://schemas.openxmlformats.org/drawingml/2006/main">
             <a:off x="685800" y="3162300"/>
-            <a:ext cx="4048125" cy="647700"/>
+            <a:ext cx="3381375" cy="647700"/>
           </a:xfrm>
           <a:prstGeom xmlns:a="http://schemas.openxmlformats.org/drawingml/2006/main" prst="rect">
             <a:avLst/>
@@ -12523,7 +12323,7 @@
           <p:cNvPr id="5" name="">
             <a:extLst xmlns:a="http://schemas.openxmlformats.org/drawingml/2006/main">
               <a:ext uri="{FF2B5EF4-FFF2-40B4-BE49-F238E27FC236}">
-                <a16:creationId xmlns:a16="http://schemas.microsoft.com/office/drawing/2014/main" id="{E4DDD127-4A17-4806-A0D3-471E4516EF2B}"/>
+                <a16:creationId xmlns:a16="http://schemas.microsoft.com/office/drawing/2014/main" id="{FACF12C3-E5CB-4679-AEF3-EF7C843B9AB8}"/>
               </a:ext>
             </a:extLst>
           </p:cNvPr>
@@ -12535,7 +12335,7 @@
         <p:spPr>
           <a:xfrm xmlns:a="http://schemas.openxmlformats.org/drawingml/2006/main">
             <a:off x="685800" y="3962400"/>
-            <a:ext cx="4048125" cy="647700"/>
+            <a:ext cx="3381375" cy="647700"/>
           </a:xfrm>
           <a:prstGeom xmlns:a="http://schemas.openxmlformats.org/drawingml/2006/main" prst="rect">
             <a:avLst/>
@@ -12681,7 +12481,7 @@
           <p:cNvPr id="6" name="">
             <a:extLst xmlns:a="http://schemas.openxmlformats.org/drawingml/2006/main">
               <a:ext uri="{FF2B5EF4-FFF2-40B4-BE49-F238E27FC236}">
-                <a16:creationId xmlns:a16="http://schemas.microsoft.com/office/drawing/2014/main" id="{C0BE01E2-9111-47AB-84A2-AF2112A2A908}"/>
+                <a16:creationId xmlns:a16="http://schemas.microsoft.com/office/drawing/2014/main" id="{52203C3A-0DAE-454A-8F3F-2A9B4F5E10C1}"/>
               </a:ext>
             </a:extLst>
           </p:cNvPr>
@@ -12693,7 +12493,7 @@
         <p:spPr>
           <a:xfrm xmlns:a="http://schemas.openxmlformats.org/drawingml/2006/main">
             <a:off x="685800" y="4762500"/>
-            <a:ext cx="4048125" cy="647700"/>
+            <a:ext cx="3381375" cy="647700"/>
           </a:xfrm>
           <a:prstGeom xmlns:a="http://schemas.openxmlformats.org/drawingml/2006/main" prst="rect">
             <a:avLst/>
@@ -12839,7 +12639,7 @@
           <p:cNvPr id="7" name="">
             <a:extLst xmlns:a="http://schemas.openxmlformats.org/drawingml/2006/main">
               <a:ext uri="{FF2B5EF4-FFF2-40B4-BE49-F238E27FC236}">
-                <a16:creationId xmlns:a16="http://schemas.microsoft.com/office/drawing/2014/main" id="{49ACA95B-4D80-49FD-B09A-4A533467F66F}"/>
+                <a16:creationId xmlns:a16="http://schemas.microsoft.com/office/drawing/2014/main" id="{8F7B3950-D70A-42DF-9202-C0517FFED682}"/>
               </a:ext>
             </a:extLst>
           </p:cNvPr>
@@ -12849,13 +12649,13 @@
           <p:nvPr/>
         </p:nvPicPr>
         <p:blipFill>
-          <a:blip xmlns:r="http://schemas.openxmlformats.org/officeDocument/2006/relationships" xmlns:a="http://schemas.openxmlformats.org/drawingml/2006/main" r:embed="Rd91fd5fe7105485d"/>
+          <a:blip xmlns:r="http://schemas.openxmlformats.org/officeDocument/2006/relationships" xmlns:a="http://schemas.openxmlformats.org/drawingml/2006/main" r:embed="R8dbf191aa0e44bd2"/>
           <a:stretch xmlns:a="http://schemas.openxmlformats.org/drawingml/2006/main"/>
         </p:blipFill>
         <p:spPr>
           <a:xfrm xmlns:a="http://schemas.openxmlformats.org/drawingml/2006/main">
-            <a:off x="5049393" y="1438275"/>
-            <a:ext cx="6569964" cy="4562475"/>
+            <a:off x="4429125" y="1386604"/>
+            <a:ext cx="7143750" cy="4846792"/>
           </a:xfrm>
           <a:prstGeom xmlns:a="http://schemas.openxmlformats.org/drawingml/2006/main" prst="rect">
             <a:avLst/>
@@ -12867,7 +12667,7 @@
           <p:cNvPr id="8" name="">
             <a:extLst xmlns:a="http://schemas.openxmlformats.org/drawingml/2006/main">
               <a:ext uri="{FF2B5EF4-FFF2-40B4-BE49-F238E27FC236}">
-                <a16:creationId xmlns:a16="http://schemas.microsoft.com/office/drawing/2014/main" id="{5FA48DDC-3F75-4715-A0BD-92B6741A22DF}"/>
+                <a16:creationId xmlns:a16="http://schemas.microsoft.com/office/drawing/2014/main" id="{D24A1041-6892-4992-91DE-D107CD42EE37}"/>
               </a:ext>
             </a:extLst>
           </p:cNvPr>
@@ -13023,7 +12823,7 @@
     </p:spTree>
     <p:extLst>
       <p:ext uri="{BB962C8B-B14F-4D97-AF65-F5344CB8AC3E}">
-        <p14:creationId xmlns:p14="http://schemas.microsoft.com/office/powerpoint/2010/main" val="1810317435"/>
+        <p14:creationId xmlns:p14="http://schemas.microsoft.com/office/powerpoint/2010/main" val="478118447"/>
       </p:ext>
     </p:extLst>
   </p:cSld>
@@ -13054,7 +12854,7 @@
           <p:cNvPr id="9" name="">
             <a:extLst xmlns:a="http://schemas.openxmlformats.org/drawingml/2006/main">
               <a:ext uri="{FF2B5EF4-FFF2-40B4-BE49-F238E27FC236}">
-                <a16:creationId xmlns:a16="http://schemas.microsoft.com/office/drawing/2014/main" id="{8BEC3D80-564B-4A86-BFF6-879086049438}"/>
+                <a16:creationId xmlns:a16="http://schemas.microsoft.com/office/drawing/2014/main" id="{3FDF5EE7-17DE-44A9-806E-A21F25924CC1}"/>
               </a:ext>
             </a:extLst>
           </p:cNvPr>
@@ -13212,7 +13012,7 @@
           <p:cNvPr id="2" name="">
             <a:extLst xmlns:a="http://schemas.openxmlformats.org/drawingml/2006/main">
               <a:ext uri="{FF2B5EF4-FFF2-40B4-BE49-F238E27FC236}">
-                <a16:creationId xmlns:a16="http://schemas.microsoft.com/office/drawing/2014/main" id="{AF09887A-AF98-4742-9033-81CC15B6BABE}"/>
+                <a16:creationId xmlns:a16="http://schemas.microsoft.com/office/drawing/2014/main" id="{767B96FC-E2A0-4452-9433-865CE580991F}"/>
               </a:ext>
             </a:extLst>
           </p:cNvPr>
@@ -13224,7 +13024,7 @@
         <p:spPr>
           <a:xfrm xmlns:a="http://schemas.openxmlformats.org/drawingml/2006/main">
             <a:off x="685800" y="1562100"/>
-            <a:ext cx="4048125" cy="647700"/>
+            <a:ext cx="3381375" cy="647700"/>
           </a:xfrm>
           <a:prstGeom xmlns:a="http://schemas.openxmlformats.org/drawingml/2006/main" prst="rect">
             <a:avLst/>
@@ -13370,7 +13170,7 @@
           <p:cNvPr id="3" name="">
             <a:extLst xmlns:a="http://schemas.openxmlformats.org/drawingml/2006/main">
               <a:ext uri="{FF2B5EF4-FFF2-40B4-BE49-F238E27FC236}">
-                <a16:creationId xmlns:a16="http://schemas.microsoft.com/office/drawing/2014/main" id="{A350DCE9-7A0F-4E64-911A-D939F29849C0}"/>
+                <a16:creationId xmlns:a16="http://schemas.microsoft.com/office/drawing/2014/main" id="{90FE0BDA-FC92-4C12-9B84-2BB6DD6C5D54}"/>
               </a:ext>
             </a:extLst>
           </p:cNvPr>
@@ -13382,7 +13182,7 @@
         <p:spPr>
           <a:xfrm xmlns:a="http://schemas.openxmlformats.org/drawingml/2006/main">
             <a:off x="685800" y="2362200"/>
-            <a:ext cx="4048125" cy="647700"/>
+            <a:ext cx="3381375" cy="647700"/>
           </a:xfrm>
           <a:prstGeom xmlns:a="http://schemas.openxmlformats.org/drawingml/2006/main" prst="rect">
             <a:avLst/>
@@ -13528,7 +13328,7 @@
           <p:cNvPr id="4" name="">
             <a:extLst xmlns:a="http://schemas.openxmlformats.org/drawingml/2006/main">
               <a:ext uri="{FF2B5EF4-FFF2-40B4-BE49-F238E27FC236}">
-                <a16:creationId xmlns:a16="http://schemas.microsoft.com/office/drawing/2014/main" id="{9661FF35-298B-43AA-A610-E62DCB6E1EDB}"/>
+                <a16:creationId xmlns:a16="http://schemas.microsoft.com/office/drawing/2014/main" id="{D8B4371F-E5F2-4967-AD10-57D772460145}"/>
               </a:ext>
             </a:extLst>
           </p:cNvPr>
@@ -13540,7 +13340,7 @@
         <p:spPr>
           <a:xfrm xmlns:a="http://schemas.openxmlformats.org/drawingml/2006/main">
             <a:off x="685800" y="3162300"/>
-            <a:ext cx="4048125" cy="647700"/>
+            <a:ext cx="3381375" cy="647700"/>
           </a:xfrm>
           <a:prstGeom xmlns:a="http://schemas.openxmlformats.org/drawingml/2006/main" prst="rect">
             <a:avLst/>
@@ -13686,7 +13486,7 @@
           <p:cNvPr id="5" name="">
             <a:extLst xmlns:a="http://schemas.openxmlformats.org/drawingml/2006/main">
               <a:ext uri="{FF2B5EF4-FFF2-40B4-BE49-F238E27FC236}">
-                <a16:creationId xmlns:a16="http://schemas.microsoft.com/office/drawing/2014/main" id="{53CC53D5-1EEA-4265-8454-2F61976FC0DB}"/>
+                <a16:creationId xmlns:a16="http://schemas.microsoft.com/office/drawing/2014/main" id="{338F93E1-75D9-4D90-B89E-116922CCBC75}"/>
               </a:ext>
             </a:extLst>
           </p:cNvPr>
@@ -13698,7 +13498,7 @@
         <p:spPr>
           <a:xfrm xmlns:a="http://schemas.openxmlformats.org/drawingml/2006/main">
             <a:off x="685800" y="3962400"/>
-            <a:ext cx="4048125" cy="647700"/>
+            <a:ext cx="3381375" cy="647700"/>
           </a:xfrm>
           <a:prstGeom xmlns:a="http://schemas.openxmlformats.org/drawingml/2006/main" prst="rect">
             <a:avLst/>
@@ -13844,7 +13644,7 @@
           <p:cNvPr id="6" name="">
             <a:extLst xmlns:a="http://schemas.openxmlformats.org/drawingml/2006/main">
               <a:ext uri="{FF2B5EF4-FFF2-40B4-BE49-F238E27FC236}">
-                <a16:creationId xmlns:a16="http://schemas.microsoft.com/office/drawing/2014/main" id="{8E36D865-241A-4D6E-AB43-8F5B3C4F1E43}"/>
+                <a16:creationId xmlns:a16="http://schemas.microsoft.com/office/drawing/2014/main" id="{6646B2F6-025B-4EF9-9D66-E913F6DBB155}"/>
               </a:ext>
             </a:extLst>
           </p:cNvPr>
@@ -13856,7 +13656,7 @@
         <p:spPr>
           <a:xfrm xmlns:a="http://schemas.openxmlformats.org/drawingml/2006/main">
             <a:off x="685800" y="4762500"/>
-            <a:ext cx="4048125" cy="647700"/>
+            <a:ext cx="3381375" cy="647700"/>
           </a:xfrm>
           <a:prstGeom xmlns:a="http://schemas.openxmlformats.org/drawingml/2006/main" prst="rect">
             <a:avLst/>
@@ -14002,7 +13802,7 @@
           <p:cNvPr id="7" name="">
             <a:extLst xmlns:a="http://schemas.openxmlformats.org/drawingml/2006/main">
               <a:ext uri="{FF2B5EF4-FFF2-40B4-BE49-F238E27FC236}">
-                <a16:creationId xmlns:a16="http://schemas.microsoft.com/office/drawing/2014/main" id="{E79E8A6E-392E-4503-AD54-F80F3D47E928}"/>
+                <a16:creationId xmlns:a16="http://schemas.microsoft.com/office/drawing/2014/main" id="{4B18563C-670A-4E3B-A0D2-5361BBBFFE1F}"/>
               </a:ext>
             </a:extLst>
           </p:cNvPr>
@@ -14012,13 +13812,13 @@
           <p:nvPr/>
         </p:nvPicPr>
         <p:blipFill>
-          <a:blip xmlns:r="http://schemas.openxmlformats.org/officeDocument/2006/relationships" xmlns:a="http://schemas.openxmlformats.org/drawingml/2006/main" r:embed="Rf5fc5b8ca3444d4a"/>
+          <a:blip xmlns:r="http://schemas.openxmlformats.org/officeDocument/2006/relationships" xmlns:a="http://schemas.openxmlformats.org/drawingml/2006/main" r:embed="R0de4e8be4fc6418e"/>
           <a:stretch xmlns:a="http://schemas.openxmlformats.org/drawingml/2006/main"/>
         </p:blipFill>
         <p:spPr>
           <a:xfrm xmlns:a="http://schemas.openxmlformats.org/drawingml/2006/main">
-            <a:off x="5049393" y="1438275"/>
-            <a:ext cx="6569964" cy="4562475"/>
+            <a:off x="4429125" y="2580968"/>
+            <a:ext cx="7143750" cy="2458065"/>
           </a:xfrm>
           <a:prstGeom xmlns:a="http://schemas.openxmlformats.org/drawingml/2006/main" prst="rect">
             <a:avLst/>
@@ -14030,7 +13830,7 @@
           <p:cNvPr id="8" name="">
             <a:extLst xmlns:a="http://schemas.openxmlformats.org/drawingml/2006/main">
               <a:ext uri="{FF2B5EF4-FFF2-40B4-BE49-F238E27FC236}">
-                <a16:creationId xmlns:a16="http://schemas.microsoft.com/office/drawing/2014/main" id="{81CF6440-15A8-4A94-BF2B-3F435D6A2EE0}"/>
+                <a16:creationId xmlns:a16="http://schemas.microsoft.com/office/drawing/2014/main" id="{AA28BD44-D5F7-45DE-AF66-06687B248CA8}"/>
               </a:ext>
             </a:extLst>
           </p:cNvPr>
@@ -14186,7 +13986,7 @@
     </p:spTree>
     <p:extLst>
       <p:ext uri="{BB962C8B-B14F-4D97-AF65-F5344CB8AC3E}">
-        <p14:creationId xmlns:p14="http://schemas.microsoft.com/office/powerpoint/2010/main" val="109856109"/>
+        <p14:creationId xmlns:p14="http://schemas.microsoft.com/office/powerpoint/2010/main" val="265704214"/>
       </p:ext>
     </p:extLst>
   </p:cSld>
@@ -14217,7 +14017,7 @@
           <p:cNvPr id="9" name="">
             <a:extLst xmlns:a="http://schemas.openxmlformats.org/drawingml/2006/main">
               <a:ext uri="{FF2B5EF4-FFF2-40B4-BE49-F238E27FC236}">
-                <a16:creationId xmlns:a16="http://schemas.microsoft.com/office/drawing/2014/main" id="{921BF0FA-D27F-49D8-8F54-1069A0CDA3BF}"/>
+                <a16:creationId xmlns:a16="http://schemas.microsoft.com/office/drawing/2014/main" id="{CC59DAB0-78AA-42A3-B72D-45ABD44C7BE7}"/>
               </a:ext>
             </a:extLst>
           </p:cNvPr>
@@ -14375,7 +14175,7 @@
           <p:cNvPr id="2" name="">
             <a:extLst xmlns:a="http://schemas.openxmlformats.org/drawingml/2006/main">
               <a:ext uri="{FF2B5EF4-FFF2-40B4-BE49-F238E27FC236}">
-                <a16:creationId xmlns:a16="http://schemas.microsoft.com/office/drawing/2014/main" id="{B47F67B0-84CC-4B9B-A124-AF06EC0A36DE}"/>
+                <a16:creationId xmlns:a16="http://schemas.microsoft.com/office/drawing/2014/main" id="{BA5E26AA-FAA9-46A9-BEAC-47DB96D3AE62}"/>
               </a:ext>
             </a:extLst>
           </p:cNvPr>
@@ -14387,7 +14187,7 @@
         <p:spPr>
           <a:xfrm xmlns:a="http://schemas.openxmlformats.org/drawingml/2006/main">
             <a:off x="685800" y="1562100"/>
-            <a:ext cx="4048125" cy="647700"/>
+            <a:ext cx="3381375" cy="647700"/>
           </a:xfrm>
           <a:prstGeom xmlns:a="http://schemas.openxmlformats.org/drawingml/2006/main" prst="rect">
             <a:avLst/>
@@ -14533,7 +14333,7 @@
           <p:cNvPr id="3" name="">
             <a:extLst xmlns:a="http://schemas.openxmlformats.org/drawingml/2006/main">
               <a:ext uri="{FF2B5EF4-FFF2-40B4-BE49-F238E27FC236}">
-                <a16:creationId xmlns:a16="http://schemas.microsoft.com/office/drawing/2014/main" id="{44D71FA1-AD5F-4B2C-9153-15CCADE74E87}"/>
+                <a16:creationId xmlns:a16="http://schemas.microsoft.com/office/drawing/2014/main" id="{C81172DD-B8CF-48E3-BE19-C3844F60E05C}"/>
               </a:ext>
             </a:extLst>
           </p:cNvPr>
@@ -14545,7 +14345,7 @@
         <p:spPr>
           <a:xfrm xmlns:a="http://schemas.openxmlformats.org/drawingml/2006/main">
             <a:off x="685800" y="2362200"/>
-            <a:ext cx="4048125" cy="647700"/>
+            <a:ext cx="3381375" cy="647700"/>
           </a:xfrm>
           <a:prstGeom xmlns:a="http://schemas.openxmlformats.org/drawingml/2006/main" prst="rect">
             <a:avLst/>
@@ -14691,7 +14491,7 @@
           <p:cNvPr id="4" name="">
             <a:extLst xmlns:a="http://schemas.openxmlformats.org/drawingml/2006/main">
               <a:ext uri="{FF2B5EF4-FFF2-40B4-BE49-F238E27FC236}">
-                <a16:creationId xmlns:a16="http://schemas.microsoft.com/office/drawing/2014/main" id="{3A1DDE26-FF95-4FE2-8E2A-E7D932AA7887}"/>
+                <a16:creationId xmlns:a16="http://schemas.microsoft.com/office/drawing/2014/main" id="{A8612563-E9A3-47C2-AD23-4D90865447D7}"/>
               </a:ext>
             </a:extLst>
           </p:cNvPr>
@@ -14703,7 +14503,7 @@
         <p:spPr>
           <a:xfrm xmlns:a="http://schemas.openxmlformats.org/drawingml/2006/main">
             <a:off x="685800" y="3162300"/>
-            <a:ext cx="4048125" cy="647700"/>
+            <a:ext cx="3381375" cy="647700"/>
           </a:xfrm>
           <a:prstGeom xmlns:a="http://schemas.openxmlformats.org/drawingml/2006/main" prst="rect">
             <a:avLst/>
@@ -14849,7 +14649,7 @@
           <p:cNvPr id="5" name="">
             <a:extLst xmlns:a="http://schemas.openxmlformats.org/drawingml/2006/main">
               <a:ext uri="{FF2B5EF4-FFF2-40B4-BE49-F238E27FC236}">
-                <a16:creationId xmlns:a16="http://schemas.microsoft.com/office/drawing/2014/main" id="{54035D1A-F09F-48C3-A568-A08682AF21CC}"/>
+                <a16:creationId xmlns:a16="http://schemas.microsoft.com/office/drawing/2014/main" id="{65506C06-886B-4391-930C-3B9129B61514}"/>
               </a:ext>
             </a:extLst>
           </p:cNvPr>
@@ -14861,7 +14661,7 @@
         <p:spPr>
           <a:xfrm xmlns:a="http://schemas.openxmlformats.org/drawingml/2006/main">
             <a:off x="685800" y="3962400"/>
-            <a:ext cx="4048125" cy="647700"/>
+            <a:ext cx="3381375" cy="647700"/>
           </a:xfrm>
           <a:prstGeom xmlns:a="http://schemas.openxmlformats.org/drawingml/2006/main" prst="rect">
             <a:avLst/>
@@ -15007,7 +14807,7 @@
           <p:cNvPr id="6" name="">
             <a:extLst xmlns:a="http://schemas.openxmlformats.org/drawingml/2006/main">
               <a:ext uri="{FF2B5EF4-FFF2-40B4-BE49-F238E27FC236}">
-                <a16:creationId xmlns:a16="http://schemas.microsoft.com/office/drawing/2014/main" id="{B4966389-7390-4A9B-9377-D73A85871704}"/>
+                <a16:creationId xmlns:a16="http://schemas.microsoft.com/office/drawing/2014/main" id="{DECA6DA8-AAD6-421A-A766-371516107715}"/>
               </a:ext>
             </a:extLst>
           </p:cNvPr>
@@ -15019,7 +14819,7 @@
         <p:spPr>
           <a:xfrm xmlns:a="http://schemas.openxmlformats.org/drawingml/2006/main">
             <a:off x="685800" y="4762500"/>
-            <a:ext cx="4048125" cy="647700"/>
+            <a:ext cx="3381375" cy="647700"/>
           </a:xfrm>
           <a:prstGeom xmlns:a="http://schemas.openxmlformats.org/drawingml/2006/main" prst="rect">
             <a:avLst/>
@@ -15165,7 +14965,7 @@
           <p:cNvPr id="7" name="">
             <a:extLst xmlns:a="http://schemas.openxmlformats.org/drawingml/2006/main">
               <a:ext uri="{FF2B5EF4-FFF2-40B4-BE49-F238E27FC236}">
-                <a16:creationId xmlns:a16="http://schemas.microsoft.com/office/drawing/2014/main" id="{3C0568AA-9FE8-476A-A009-1C8052099BF4}"/>
+                <a16:creationId xmlns:a16="http://schemas.microsoft.com/office/drawing/2014/main" id="{993214D2-D73F-4C52-9C2A-CD74100105C7}"/>
               </a:ext>
             </a:extLst>
           </p:cNvPr>
@@ -15175,13 +14975,13 @@
           <p:nvPr/>
         </p:nvPicPr>
         <p:blipFill>
-          <a:blip xmlns:r="http://schemas.openxmlformats.org/officeDocument/2006/relationships" xmlns:a="http://schemas.openxmlformats.org/drawingml/2006/main" r:embed="R15721367b62f4067"/>
+          <a:blip xmlns:r="http://schemas.openxmlformats.org/officeDocument/2006/relationships" xmlns:a="http://schemas.openxmlformats.org/drawingml/2006/main" r:embed="Re939ff761e2245ca"/>
           <a:stretch xmlns:a="http://schemas.openxmlformats.org/drawingml/2006/main"/>
         </p:blipFill>
         <p:spPr>
           <a:xfrm xmlns:a="http://schemas.openxmlformats.org/drawingml/2006/main">
-            <a:off x="5049393" y="1438275"/>
-            <a:ext cx="6569964" cy="4562475"/>
+            <a:off x="4465638" y="1381125"/>
+            <a:ext cx="7070725" cy="4857750"/>
           </a:xfrm>
           <a:prstGeom xmlns:a="http://schemas.openxmlformats.org/drawingml/2006/main" prst="rect">
             <a:avLst/>
@@ -15193,7 +14993,7 @@
           <p:cNvPr id="8" name="">
             <a:extLst xmlns:a="http://schemas.openxmlformats.org/drawingml/2006/main">
               <a:ext uri="{FF2B5EF4-FFF2-40B4-BE49-F238E27FC236}">
-                <a16:creationId xmlns:a16="http://schemas.microsoft.com/office/drawing/2014/main" id="{7535F4AF-E934-4F66-9DF6-98C7DD372EC0}"/>
+                <a16:creationId xmlns:a16="http://schemas.microsoft.com/office/drawing/2014/main" id="{30249455-7862-44CD-B908-0E626C60D169}"/>
               </a:ext>
             </a:extLst>
           </p:cNvPr>
@@ -15349,7 +15149,7 @@
     </p:spTree>
     <p:extLst>
       <p:ext uri="{BB962C8B-B14F-4D97-AF65-F5344CB8AC3E}">
-        <p14:creationId xmlns:p14="http://schemas.microsoft.com/office/powerpoint/2010/main" val="506186470"/>
+        <p14:creationId xmlns:p14="http://schemas.microsoft.com/office/powerpoint/2010/main" val="756018556"/>
       </p:ext>
     </p:extLst>
   </p:cSld>

</xml_diff>

<commit_message>
docs: avoid clipped columns in screenshots
</commit_message>
<xml_diff>
--- a/docs/presentation.pptx
+++ b/docs/presentation.pptx
@@ -2,22 +2,22 @@
 <file path=ppt/presentation.xml><?xml version="1.0" encoding="utf-8"?>
 <p:presentation xmlns:p="http://schemas.openxmlformats.org/presentationml/2006/main">
   <p:sldMasterIdLst>
-    <p:sldMasterId xmlns:r="http://schemas.openxmlformats.org/officeDocument/2006/relationships" id="2147483648" r:id="Rdd5cbfa6be8447fe"/>
+    <p:sldMasterId xmlns:r="http://schemas.openxmlformats.org/officeDocument/2006/relationships" id="2147483648" r:id="R0429fd6d25a24c23"/>
   </p:sldMasterIdLst>
   <p:notesMasterIdLst>
-    <p:notesMasterId xmlns:r="http://schemas.openxmlformats.org/officeDocument/2006/relationships" r:id="Rdae8a680023042fd"/>
+    <p:notesMasterId xmlns:r="http://schemas.openxmlformats.org/officeDocument/2006/relationships" r:id="R81baf77c4b5541ea"/>
   </p:notesMasterIdLst>
   <p:sldIdLst>
-    <p:sldId xmlns:r="http://schemas.openxmlformats.org/officeDocument/2006/relationships" id="256" r:id="R8d030d4a3bbe4f3f"/>
-    <p:sldId xmlns:r="http://schemas.openxmlformats.org/officeDocument/2006/relationships" id="257" r:id="R6acfb19f687448ae"/>
-    <p:sldId xmlns:r="http://schemas.openxmlformats.org/officeDocument/2006/relationships" id="258" r:id="R110016286881442f"/>
-    <p:sldId xmlns:r="http://schemas.openxmlformats.org/officeDocument/2006/relationships" id="259" r:id="R71ca9f09cc3f41ea"/>
-    <p:sldId xmlns:r="http://schemas.openxmlformats.org/officeDocument/2006/relationships" id="260" r:id="R363f72bea75f47d4"/>
-    <p:sldId xmlns:r="http://schemas.openxmlformats.org/officeDocument/2006/relationships" id="261" r:id="Ree879fca39c140be"/>
-    <p:sldId xmlns:r="http://schemas.openxmlformats.org/officeDocument/2006/relationships" id="262" r:id="R2482cb69c4d94fce"/>
-    <p:sldId xmlns:r="http://schemas.openxmlformats.org/officeDocument/2006/relationships" id="263" r:id="R3697711b50d54a41"/>
-    <p:sldId xmlns:r="http://schemas.openxmlformats.org/officeDocument/2006/relationships" id="264" r:id="R3eefa9877de542e8"/>
-    <p:sldId xmlns:r="http://schemas.openxmlformats.org/officeDocument/2006/relationships" id="265" r:id="Rb8c1bb581cde49df"/>
+    <p:sldId xmlns:r="http://schemas.openxmlformats.org/officeDocument/2006/relationships" id="256" r:id="R19d9034400f84283"/>
+    <p:sldId xmlns:r="http://schemas.openxmlformats.org/officeDocument/2006/relationships" id="257" r:id="R6156ddb63b2f45cf"/>
+    <p:sldId xmlns:r="http://schemas.openxmlformats.org/officeDocument/2006/relationships" id="258" r:id="Rcffa7e3c2c244652"/>
+    <p:sldId xmlns:r="http://schemas.openxmlformats.org/officeDocument/2006/relationships" id="259" r:id="R0c04cfba6bb64c11"/>
+    <p:sldId xmlns:r="http://schemas.openxmlformats.org/officeDocument/2006/relationships" id="260" r:id="R1a516f7742c64c1d"/>
+    <p:sldId xmlns:r="http://schemas.openxmlformats.org/officeDocument/2006/relationships" id="261" r:id="R50a7475e1cff41c0"/>
+    <p:sldId xmlns:r="http://schemas.openxmlformats.org/officeDocument/2006/relationships" id="262" r:id="R47e02d0376a241a2"/>
+    <p:sldId xmlns:r="http://schemas.openxmlformats.org/officeDocument/2006/relationships" id="263" r:id="R6fe8383c0ab742f3"/>
+    <p:sldId xmlns:r="http://schemas.openxmlformats.org/officeDocument/2006/relationships" id="264" r:id="Re4b418881bc14282"/>
+    <p:sldId xmlns:r="http://schemas.openxmlformats.org/officeDocument/2006/relationships" id="265" r:id="Rfb6dbee10af34145"/>
   </p:sldIdLst>
   <p:sldSz cx="12192000" cy="6858000"/>
   <p:notesSz cx="6858000" cy="9144000"/>
@@ -1278,7 +1278,7 @@
           <p:cNvPr id="3" name="Title">
             <a:extLst xmlns:a="http://schemas.openxmlformats.org/drawingml/2006/main">
               <a:ext uri="{FF2B5EF4-FFF2-40B4-BE49-F238E27FC236}">
-                <a16:creationId xmlns:a16="http://schemas.microsoft.com/office/drawing/2014/main" id="{E516E3B5-7BDB-4336-880A-B39D75B377BC}"/>
+                <a16:creationId xmlns:a16="http://schemas.microsoft.com/office/drawing/2014/main" id="{CB55E377-481D-48C8-976F-914896928797}"/>
               </a:ext>
             </a:extLst>
           </p:cNvPr>
@@ -1507,7 +1507,7 @@
           <p:cNvPr id="2" name="Subtitle">
             <a:extLst xmlns:a="http://schemas.openxmlformats.org/drawingml/2006/main">
               <a:ext uri="{FF2B5EF4-FFF2-40B4-BE49-F238E27FC236}">
-                <a16:creationId xmlns:a16="http://schemas.microsoft.com/office/drawing/2014/main" id="{6E726BE8-42B9-429D-B405-657DE2197808}"/>
+                <a16:creationId xmlns:a16="http://schemas.microsoft.com/office/drawing/2014/main" id="{C7663213-12AA-41A5-A26F-A401E7558301}"/>
               </a:ext>
             </a:extLst>
           </p:cNvPr>
@@ -1753,7 +1753,7 @@
           <p:cNvPr id="2" name="Section title">
             <a:extLst xmlns:a="http://schemas.openxmlformats.org/drawingml/2006/main">
               <a:ext uri="{FF2B5EF4-FFF2-40B4-BE49-F238E27FC236}">
-                <a16:creationId xmlns:a16="http://schemas.microsoft.com/office/drawing/2014/main" id="{99154102-CC34-4746-8FBB-4F92219E7927}"/>
+                <a16:creationId xmlns:a16="http://schemas.microsoft.com/office/drawing/2014/main" id="{FE57C51F-BBD3-4B25-8D2A-68E492667A57}"/>
               </a:ext>
             </a:extLst>
           </p:cNvPr>
@@ -1999,7 +1999,7 @@
           <p:cNvPr id="3" name="Title">
             <a:extLst xmlns:a="http://schemas.openxmlformats.org/drawingml/2006/main">
               <a:ext uri="{FF2B5EF4-FFF2-40B4-BE49-F238E27FC236}">
-                <a16:creationId xmlns:a16="http://schemas.microsoft.com/office/drawing/2014/main" id="{DB7C8771-40D3-41CD-AAB5-82C5F5E348EA}"/>
+                <a16:creationId xmlns:a16="http://schemas.microsoft.com/office/drawing/2014/main" id="{54133C6D-AFF7-480C-AA3B-1FE7B472B164}"/>
               </a:ext>
             </a:extLst>
           </p:cNvPr>
@@ -2228,7 +2228,7 @@
           <p:cNvPr id="2" name="Body">
             <a:extLst xmlns:a="http://schemas.openxmlformats.org/drawingml/2006/main">
               <a:ext uri="{FF2B5EF4-FFF2-40B4-BE49-F238E27FC236}">
-                <a16:creationId xmlns:a16="http://schemas.microsoft.com/office/drawing/2014/main" id="{B33609E2-1F1E-429E-AA82-49FB55E809FD}"/>
+                <a16:creationId xmlns:a16="http://schemas.microsoft.com/office/drawing/2014/main" id="{1A2B0EDB-754F-4D9A-BDF1-6F513595B0F8}"/>
               </a:ext>
             </a:extLst>
           </p:cNvPr>
@@ -2474,7 +2474,7 @@
           <p:cNvPr id="4" name="Title">
             <a:extLst xmlns:a="http://schemas.openxmlformats.org/drawingml/2006/main">
               <a:ext uri="{FF2B5EF4-FFF2-40B4-BE49-F238E27FC236}">
-                <a16:creationId xmlns:a16="http://schemas.microsoft.com/office/drawing/2014/main" id="{5CF17303-AF8B-4033-95C4-C0B36A81716B}"/>
+                <a16:creationId xmlns:a16="http://schemas.microsoft.com/office/drawing/2014/main" id="{9A35DAA8-D4C2-4C76-AE41-8A4CAB136216}"/>
               </a:ext>
             </a:extLst>
           </p:cNvPr>
@@ -2703,7 +2703,7 @@
           <p:cNvPr id="2" name="Left column">
             <a:extLst xmlns:a="http://schemas.openxmlformats.org/drawingml/2006/main">
               <a:ext uri="{FF2B5EF4-FFF2-40B4-BE49-F238E27FC236}">
-                <a16:creationId xmlns:a16="http://schemas.microsoft.com/office/drawing/2014/main" id="{38D66F79-43B0-4EA7-B461-39D5BEB21547}"/>
+                <a16:creationId xmlns:a16="http://schemas.microsoft.com/office/drawing/2014/main" id="{F3883F1B-209E-4896-B776-00DE8D049245}"/>
               </a:ext>
             </a:extLst>
           </p:cNvPr>
@@ -2932,7 +2932,7 @@
           <p:cNvPr id="3" name="Right column">
             <a:extLst xmlns:a="http://schemas.openxmlformats.org/drawingml/2006/main">
               <a:ext uri="{FF2B5EF4-FFF2-40B4-BE49-F238E27FC236}">
-                <a16:creationId xmlns:a16="http://schemas.microsoft.com/office/drawing/2014/main" id="{4B9E4031-7EBD-4E0E-A917-3AC002015194}"/>
+                <a16:creationId xmlns:a16="http://schemas.microsoft.com/office/drawing/2014/main" id="{7E945DF5-6C62-4B75-9708-EAC9777AE25E}"/>
               </a:ext>
             </a:extLst>
           </p:cNvPr>
@@ -3178,7 +3178,7 @@
           <p:cNvPr id="3" name="Title">
             <a:extLst xmlns:a="http://schemas.openxmlformats.org/drawingml/2006/main">
               <a:ext uri="{FF2B5EF4-FFF2-40B4-BE49-F238E27FC236}">
-                <a16:creationId xmlns:a16="http://schemas.microsoft.com/office/drawing/2014/main" id="{41CD51F2-982C-487D-AAA5-4959B56FB19B}"/>
+                <a16:creationId xmlns:a16="http://schemas.microsoft.com/office/drawing/2014/main" id="{C58FC49D-D076-4387-9632-C0237218A5BF}"/>
               </a:ext>
             </a:extLst>
           </p:cNvPr>
@@ -3407,7 +3407,7 @@
           <p:cNvPr id="2" name="Left column">
             <a:extLst xmlns:a="http://schemas.openxmlformats.org/drawingml/2006/main">
               <a:ext uri="{FF2B5EF4-FFF2-40B4-BE49-F238E27FC236}">
-                <a16:creationId xmlns:a16="http://schemas.microsoft.com/office/drawing/2014/main" id="{7ED73F9B-0126-4EF1-8D78-915DA796C248}"/>
+                <a16:creationId xmlns:a16="http://schemas.microsoft.com/office/drawing/2014/main" id="{30B6FD23-7B7A-4963-9542-1C6EC5FCD653}"/>
               </a:ext>
             </a:extLst>
           </p:cNvPr>
@@ -3674,12 +3674,12 @@
   </p:cSld>
   <p:clrMap bg1="lt1" tx1="dk1" bg2="lt2" tx2="dk2" accent1="accent1" accent2="accent2" accent3="accent3" accent4="accent4" accent5="accent5" accent6="accent6" hlink="hlink" folHlink="folHlink"/>
   <p:sldLayoutIdLst>
-    <p:sldLayoutId xmlns:r="http://schemas.openxmlformats.org/officeDocument/2006/relationships" id="2147483649" r:id="R8aa71702010341e6"/>
-    <p:sldLayoutId xmlns:r="http://schemas.openxmlformats.org/officeDocument/2006/relationships" id="2147483650" r:id="Rf07e659285fb45d8"/>
-    <p:sldLayoutId xmlns:r="http://schemas.openxmlformats.org/officeDocument/2006/relationships" id="2147483651" r:id="R1811e3a9a26f4ddb"/>
-    <p:sldLayoutId xmlns:r="http://schemas.openxmlformats.org/officeDocument/2006/relationships" id="2147483652" r:id="R4efb014ec8154442"/>
-    <p:sldLayoutId xmlns:r="http://schemas.openxmlformats.org/officeDocument/2006/relationships" id="2147483653" r:id="R925477ae893c4f51"/>
-    <p:sldLayoutId xmlns:r="http://schemas.openxmlformats.org/officeDocument/2006/relationships" id="2147483654" r:id="R56a422d651ae4978"/>
+    <p:sldLayoutId xmlns:r="http://schemas.openxmlformats.org/officeDocument/2006/relationships" id="2147483649" r:id="R6aca07d9e5634f32"/>
+    <p:sldLayoutId xmlns:r="http://schemas.openxmlformats.org/officeDocument/2006/relationships" id="2147483650" r:id="R4c0af00792474aa5"/>
+    <p:sldLayoutId xmlns:r="http://schemas.openxmlformats.org/officeDocument/2006/relationships" id="2147483651" r:id="R9e930e7245fa448a"/>
+    <p:sldLayoutId xmlns:r="http://schemas.openxmlformats.org/officeDocument/2006/relationships" id="2147483652" r:id="R83b8d8a8cfcc4b6d"/>
+    <p:sldLayoutId xmlns:r="http://schemas.openxmlformats.org/officeDocument/2006/relationships" id="2147483653" r:id="R078b5cacc2194f1f"/>
+    <p:sldLayoutId xmlns:r="http://schemas.openxmlformats.org/officeDocument/2006/relationships" id="2147483654" r:id="Rbb5ba447b5034a7d"/>
   </p:sldLayoutIdLst>
   <p:txStyles>
     <p:titleStyle>
@@ -4230,7 +4230,7 @@
           <p:cNvPr id="4" name="">
             <a:extLst xmlns:a="http://schemas.openxmlformats.org/drawingml/2006/main">
               <a:ext uri="{FF2B5EF4-FFF2-40B4-BE49-F238E27FC236}">
-                <a16:creationId xmlns:a16="http://schemas.microsoft.com/office/drawing/2014/main" id="{CD7C41F0-B85C-4A6E-8D6B-51DEEE9B93F1}"/>
+                <a16:creationId xmlns:a16="http://schemas.microsoft.com/office/drawing/2014/main" id="{BF6075F0-4AA9-4365-82FF-3330AC67B06C}"/>
               </a:ext>
             </a:extLst>
           </p:cNvPr>
@@ -4388,7 +4388,7 @@
           <p:cNvPr id="2" name="">
             <a:extLst xmlns:a="http://schemas.openxmlformats.org/drawingml/2006/main">
               <a:ext uri="{FF2B5EF4-FFF2-40B4-BE49-F238E27FC236}">
-                <a16:creationId xmlns:a16="http://schemas.microsoft.com/office/drawing/2014/main" id="{6A8DFE38-B0C5-4DA0-9196-4FB6180C9E42}"/>
+                <a16:creationId xmlns:a16="http://schemas.microsoft.com/office/drawing/2014/main" id="{54137FAA-E8B7-4841-A6CC-67894CAE19E1}"/>
               </a:ext>
             </a:extLst>
           </p:cNvPr>
@@ -4592,7 +4592,7 @@
           <p:cNvPr id="3" name="">
             <a:extLst xmlns:a="http://schemas.openxmlformats.org/drawingml/2006/main">
               <a:ext uri="{FF2B5EF4-FFF2-40B4-BE49-F238E27FC236}">
-                <a16:creationId xmlns:a16="http://schemas.microsoft.com/office/drawing/2014/main" id="{E3639866-2A80-4C72-981A-4D173D90916C}"/>
+                <a16:creationId xmlns:a16="http://schemas.microsoft.com/office/drawing/2014/main" id="{C250CF76-9411-425E-8A3C-EAD1D7722E89}"/>
               </a:ext>
             </a:extLst>
           </p:cNvPr>
@@ -4748,7 +4748,7 @@
     </p:spTree>
     <p:extLst>
       <p:ext uri="{BB962C8B-B14F-4D97-AF65-F5344CB8AC3E}">
-        <p14:creationId xmlns:p14="http://schemas.microsoft.com/office/powerpoint/2010/main" val="1528758542"/>
+        <p14:creationId xmlns:p14="http://schemas.microsoft.com/office/powerpoint/2010/main" val="894377142"/>
       </p:ext>
     </p:extLst>
   </p:cSld>
@@ -4779,7 +4779,7 @@
           <p:cNvPr id="6" name="">
             <a:extLst xmlns:a="http://schemas.openxmlformats.org/drawingml/2006/main">
               <a:ext uri="{FF2B5EF4-FFF2-40B4-BE49-F238E27FC236}">
-                <a16:creationId xmlns:a16="http://schemas.microsoft.com/office/drawing/2014/main" id="{B278BF10-9D9A-4C87-AF9B-68909B7E2891}"/>
+                <a16:creationId xmlns:a16="http://schemas.microsoft.com/office/drawing/2014/main" id="{FB285292-17F3-4A09-B525-76F6BDA02518}"/>
               </a:ext>
             </a:extLst>
           </p:cNvPr>
@@ -4937,7 +4937,7 @@
           <p:cNvPr id="2" name="">
             <a:extLst xmlns:a="http://schemas.openxmlformats.org/drawingml/2006/main">
               <a:ext uri="{FF2B5EF4-FFF2-40B4-BE49-F238E27FC236}">
-                <a16:creationId xmlns:a16="http://schemas.microsoft.com/office/drawing/2014/main" id="{0F7786C0-9884-4170-8255-4819D2AA4CE1}"/>
+                <a16:creationId xmlns:a16="http://schemas.microsoft.com/office/drawing/2014/main" id="{531D4F14-9879-4BFB-958C-89C6F321C6D5}"/>
               </a:ext>
             </a:extLst>
           </p:cNvPr>
@@ -5377,7 +5377,7 @@
           <p:cNvPr id="3" name="">
             <a:extLst xmlns:a="http://schemas.openxmlformats.org/drawingml/2006/main">
               <a:ext uri="{FF2B5EF4-FFF2-40B4-BE49-F238E27FC236}">
-                <a16:creationId xmlns:a16="http://schemas.microsoft.com/office/drawing/2014/main" id="{B01657C5-A956-451C-B21A-6A9051387C69}"/>
+                <a16:creationId xmlns:a16="http://schemas.microsoft.com/office/drawing/2014/main" id="{F969E46A-8D90-4E3E-BD5B-E821F303ABA2}"/>
               </a:ext>
             </a:extLst>
           </p:cNvPr>
@@ -5535,7 +5535,7 @@
                 <a:latin typeface="Arial"/>
                 <a:ea typeface="Arial"/>
                 <a:cs typeface="Arial"/>
-                <a:hlinkClick xmlns:r="http://schemas.openxmlformats.org/officeDocument/2006/relationships" r:id="R2aa8d27ac5e546f7"/>
+                <a:hlinkClick xmlns:r="http://schemas.openxmlformats.org/officeDocument/2006/relationships" r:id="R6600009110d94acf"/>
               </a:rPr>
               <a:t>https://85.8.201.148/login</a:t>
             </a:r>
@@ -5547,7 +5547,7 @@
           <p:cNvPr id="4" name="">
             <a:extLst xmlns:a="http://schemas.openxmlformats.org/drawingml/2006/main">
               <a:ext uri="{FF2B5EF4-FFF2-40B4-BE49-F238E27FC236}">
-                <a16:creationId xmlns:a16="http://schemas.microsoft.com/office/drawing/2014/main" id="{1694EAC1-3AE2-4613-AC87-7BCE68666223}"/>
+                <a16:creationId xmlns:a16="http://schemas.microsoft.com/office/drawing/2014/main" id="{A6F4CA48-60E2-45F8-BF46-27E7D2B326C0}"/>
               </a:ext>
             </a:extLst>
           </p:cNvPr>
@@ -5705,7 +5705,7 @@
                 <a:latin typeface="Arial"/>
                 <a:ea typeface="Arial"/>
                 <a:cs typeface="Arial"/>
-                <a:hlinkClick xmlns:r="http://schemas.openxmlformats.org/officeDocument/2006/relationships" r:id="R362bad722c624b0e"/>
+                <a:hlinkClick xmlns:r="http://schemas.openxmlformats.org/officeDocument/2006/relationships" r:id="R9d198c323aaf42e1"/>
               </a:rPr>
               <a:t>Samirrrrr123/college-inventory</a:t>
             </a:r>
@@ -5717,7 +5717,7 @@
           <p:cNvPr id="5" name="">
             <a:extLst xmlns:a="http://schemas.openxmlformats.org/drawingml/2006/main">
               <a:ext uri="{FF2B5EF4-FFF2-40B4-BE49-F238E27FC236}">
-                <a16:creationId xmlns:a16="http://schemas.microsoft.com/office/drawing/2014/main" id="{7526572E-85CA-4284-B9F5-E62C24E0A97D}"/>
+                <a16:creationId xmlns:a16="http://schemas.microsoft.com/office/drawing/2014/main" id="{F0FC51D1-014C-41BC-AA3F-82E36B2E355D}"/>
               </a:ext>
             </a:extLst>
           </p:cNvPr>
@@ -5873,7 +5873,7 @@
     </p:spTree>
     <p:extLst>
       <p:ext uri="{BB962C8B-B14F-4D97-AF65-F5344CB8AC3E}">
-        <p14:creationId xmlns:p14="http://schemas.microsoft.com/office/powerpoint/2010/main" val="1718393992"/>
+        <p14:creationId xmlns:p14="http://schemas.microsoft.com/office/powerpoint/2010/main" val="1070478364"/>
       </p:ext>
     </p:extLst>
   </p:cSld>
@@ -5904,7 +5904,7 @@
           <p:cNvPr id="10" name="">
             <a:extLst xmlns:a="http://schemas.openxmlformats.org/drawingml/2006/main">
               <a:ext uri="{FF2B5EF4-FFF2-40B4-BE49-F238E27FC236}">
-                <a16:creationId xmlns:a16="http://schemas.microsoft.com/office/drawing/2014/main" id="{9F28A3BC-C94E-477F-8C43-254B4B54C407}"/>
+                <a16:creationId xmlns:a16="http://schemas.microsoft.com/office/drawing/2014/main" id="{3376683A-C721-4403-9FDC-F95CE950355D}"/>
               </a:ext>
             </a:extLst>
           </p:cNvPr>
@@ -6062,7 +6062,7 @@
           <p:cNvPr id="2" name="">
             <a:extLst xmlns:a="http://schemas.openxmlformats.org/drawingml/2006/main">
               <a:ext uri="{FF2B5EF4-FFF2-40B4-BE49-F238E27FC236}">
-                <a16:creationId xmlns:a16="http://schemas.microsoft.com/office/drawing/2014/main" id="{C38543F8-A221-417F-AB03-D6DE69A741BE}"/>
+                <a16:creationId xmlns:a16="http://schemas.microsoft.com/office/drawing/2014/main" id="{E2215149-9734-4838-BB9C-A4EAA83D7C1E}"/>
               </a:ext>
             </a:extLst>
           </p:cNvPr>
@@ -6220,7 +6220,7 @@
           <p:cNvPr id="3" name="">
             <a:extLst xmlns:a="http://schemas.openxmlformats.org/drawingml/2006/main">
               <a:ext uri="{FF2B5EF4-FFF2-40B4-BE49-F238E27FC236}">
-                <a16:creationId xmlns:a16="http://schemas.microsoft.com/office/drawing/2014/main" id="{2F9F203C-1E54-4A0B-A167-64361E26146E}"/>
+                <a16:creationId xmlns:a16="http://schemas.microsoft.com/office/drawing/2014/main" id="{F7567A85-E1A6-4416-BA8E-3CECF1C46ACB}"/>
               </a:ext>
             </a:extLst>
           </p:cNvPr>
@@ -6378,7 +6378,7 @@
           <p:cNvPr id="4" name="">
             <a:extLst xmlns:a="http://schemas.openxmlformats.org/drawingml/2006/main">
               <a:ext uri="{FF2B5EF4-FFF2-40B4-BE49-F238E27FC236}">
-                <a16:creationId xmlns:a16="http://schemas.microsoft.com/office/drawing/2014/main" id="{565C8BD2-077E-4022-B4C7-854216A8A002}"/>
+                <a16:creationId xmlns:a16="http://schemas.microsoft.com/office/drawing/2014/main" id="{9E824FB4-5573-404B-B5E7-2D9C560514C2}"/>
               </a:ext>
             </a:extLst>
           </p:cNvPr>
@@ -6536,7 +6536,7 @@
           <p:cNvPr id="5" name="">
             <a:extLst xmlns:a="http://schemas.openxmlformats.org/drawingml/2006/main">
               <a:ext uri="{FF2B5EF4-FFF2-40B4-BE49-F238E27FC236}">
-                <a16:creationId xmlns:a16="http://schemas.microsoft.com/office/drawing/2014/main" id="{7E77F6F7-951A-4C1A-A1BB-F7D193719788}"/>
+                <a16:creationId xmlns:a16="http://schemas.microsoft.com/office/drawing/2014/main" id="{A96B4191-1036-4E8B-9D14-AE0FB7C7A4AA}"/>
               </a:ext>
             </a:extLst>
           </p:cNvPr>
@@ -6694,7 +6694,7 @@
           <p:cNvPr id="6" name="">
             <a:extLst xmlns:a="http://schemas.openxmlformats.org/drawingml/2006/main">
               <a:ext uri="{FF2B5EF4-FFF2-40B4-BE49-F238E27FC236}">
-                <a16:creationId xmlns:a16="http://schemas.microsoft.com/office/drawing/2014/main" id="{FA673B39-019C-4C9F-9C43-B1906A44E834}"/>
+                <a16:creationId xmlns:a16="http://schemas.microsoft.com/office/drawing/2014/main" id="{F98A4D7A-A685-4DC1-A5AC-141ABD3CBB37}"/>
               </a:ext>
             </a:extLst>
           </p:cNvPr>
@@ -6852,7 +6852,7 @@
           <p:cNvPr id="7" name="">
             <a:extLst xmlns:a="http://schemas.openxmlformats.org/drawingml/2006/main">
               <a:ext uri="{FF2B5EF4-FFF2-40B4-BE49-F238E27FC236}">
-                <a16:creationId xmlns:a16="http://schemas.microsoft.com/office/drawing/2014/main" id="{4172B422-2608-444B-8C20-8C4854D54CB7}"/>
+                <a16:creationId xmlns:a16="http://schemas.microsoft.com/office/drawing/2014/main" id="{95CADA28-1DBE-4946-9507-04174995533C}"/>
               </a:ext>
             </a:extLst>
           </p:cNvPr>
@@ -7010,7 +7010,7 @@
           <p:cNvPr id="8" name="">
             <a:extLst xmlns:a="http://schemas.openxmlformats.org/drawingml/2006/main">
               <a:ext uri="{FF2B5EF4-FFF2-40B4-BE49-F238E27FC236}">
-                <a16:creationId xmlns:a16="http://schemas.microsoft.com/office/drawing/2014/main" id="{A9A3432E-69B8-4F5B-8F95-05DE988F0D2C}"/>
+                <a16:creationId xmlns:a16="http://schemas.microsoft.com/office/drawing/2014/main" id="{9B1B086B-6D53-4585-BB8E-ED27DE56E85F}"/>
               </a:ext>
             </a:extLst>
           </p:cNvPr>
@@ -7020,7 +7020,7 @@
           <p:nvPr/>
         </p:nvPicPr>
         <p:blipFill>
-          <a:blip xmlns:r="http://schemas.openxmlformats.org/officeDocument/2006/relationships" xmlns:a="http://schemas.openxmlformats.org/drawingml/2006/main" r:embed="R845049199d894512"/>
+          <a:blip xmlns:r="http://schemas.openxmlformats.org/officeDocument/2006/relationships" xmlns:a="http://schemas.openxmlformats.org/drawingml/2006/main" r:embed="Rc5ba322c5ca945fb"/>
           <a:stretch xmlns:a="http://schemas.openxmlformats.org/drawingml/2006/main"/>
         </p:blipFill>
         <p:spPr>
@@ -7038,7 +7038,7 @@
           <p:cNvPr id="9" name="">
             <a:extLst xmlns:a="http://schemas.openxmlformats.org/drawingml/2006/main">
               <a:ext uri="{FF2B5EF4-FFF2-40B4-BE49-F238E27FC236}">
-                <a16:creationId xmlns:a16="http://schemas.microsoft.com/office/drawing/2014/main" id="{E304FCE3-1D38-45EB-AF23-8AF640545BD9}"/>
+                <a16:creationId xmlns:a16="http://schemas.microsoft.com/office/drawing/2014/main" id="{D57036BE-7FF0-40FA-A151-CA4EC94AAC89}"/>
               </a:ext>
             </a:extLst>
           </p:cNvPr>
@@ -7194,7 +7194,7 @@
     </p:spTree>
     <p:extLst>
       <p:ext uri="{BB962C8B-B14F-4D97-AF65-F5344CB8AC3E}">
-        <p14:creationId xmlns:p14="http://schemas.microsoft.com/office/powerpoint/2010/main" val="1447162737"/>
+        <p14:creationId xmlns:p14="http://schemas.microsoft.com/office/powerpoint/2010/main" val="905978881"/>
       </p:ext>
     </p:extLst>
   </p:cSld>
@@ -7225,7 +7225,7 @@
           <p:cNvPr id="8" name="">
             <a:extLst xmlns:a="http://schemas.openxmlformats.org/drawingml/2006/main">
               <a:ext uri="{FF2B5EF4-FFF2-40B4-BE49-F238E27FC236}">
-                <a16:creationId xmlns:a16="http://schemas.microsoft.com/office/drawing/2014/main" id="{02B69F5A-66DC-43CE-AFC3-665BC24B1C17}"/>
+                <a16:creationId xmlns:a16="http://schemas.microsoft.com/office/drawing/2014/main" id="{B376E14E-1786-42AC-9A96-233250D64D53}"/>
               </a:ext>
             </a:extLst>
           </p:cNvPr>
@@ -7383,7 +7383,7 @@
           <p:cNvPr id="2" name="">
             <a:extLst xmlns:a="http://schemas.openxmlformats.org/drawingml/2006/main">
               <a:ext uri="{FF2B5EF4-FFF2-40B4-BE49-F238E27FC236}">
-                <a16:creationId xmlns:a16="http://schemas.microsoft.com/office/drawing/2014/main" id="{E0D0B33A-460D-48AB-B70E-C716A87AA40C}"/>
+                <a16:creationId xmlns:a16="http://schemas.microsoft.com/office/drawing/2014/main" id="{522FA6C9-AED9-46DD-ABCD-908AAE7DD9B2}"/>
               </a:ext>
             </a:extLst>
           </p:cNvPr>
@@ -7541,7 +7541,7 @@
           <p:cNvPr id="3" name="">
             <a:extLst xmlns:a="http://schemas.openxmlformats.org/drawingml/2006/main">
               <a:ext uri="{FF2B5EF4-FFF2-40B4-BE49-F238E27FC236}">
-                <a16:creationId xmlns:a16="http://schemas.microsoft.com/office/drawing/2014/main" id="{9DD9BFB6-385C-4AFE-9F66-3AD74C8EFB96}"/>
+                <a16:creationId xmlns:a16="http://schemas.microsoft.com/office/drawing/2014/main" id="{FA677C31-88BF-4E48-BF34-C332EBF1894C}"/>
               </a:ext>
             </a:extLst>
           </p:cNvPr>
@@ -7699,7 +7699,7 @@
           <p:cNvPr id="4" name="">
             <a:extLst xmlns:a="http://schemas.openxmlformats.org/drawingml/2006/main">
               <a:ext uri="{FF2B5EF4-FFF2-40B4-BE49-F238E27FC236}">
-                <a16:creationId xmlns:a16="http://schemas.microsoft.com/office/drawing/2014/main" id="{BC6E0DFC-EB7B-4BBD-BEEC-30F7E164DD22}"/>
+                <a16:creationId xmlns:a16="http://schemas.microsoft.com/office/drawing/2014/main" id="{4C61F7DD-16AD-4E75-8216-F867330019E7}"/>
               </a:ext>
             </a:extLst>
           </p:cNvPr>
@@ -7857,7 +7857,7 @@
           <p:cNvPr id="5" name="">
             <a:extLst xmlns:a="http://schemas.openxmlformats.org/drawingml/2006/main">
               <a:ext uri="{FF2B5EF4-FFF2-40B4-BE49-F238E27FC236}">
-                <a16:creationId xmlns:a16="http://schemas.microsoft.com/office/drawing/2014/main" id="{DA03BA44-6AF1-49DC-803D-3A8875F1DD99}"/>
+                <a16:creationId xmlns:a16="http://schemas.microsoft.com/office/drawing/2014/main" id="{F14C5910-801F-42CF-82D2-DEF3EF084120}"/>
               </a:ext>
             </a:extLst>
           </p:cNvPr>
@@ -8015,7 +8015,7 @@
           <p:cNvPr id="6" name="">
             <a:extLst xmlns:a="http://schemas.openxmlformats.org/drawingml/2006/main">
               <a:ext uri="{FF2B5EF4-FFF2-40B4-BE49-F238E27FC236}">
-                <a16:creationId xmlns:a16="http://schemas.microsoft.com/office/drawing/2014/main" id="{A2908381-BA3C-40F0-911B-C6AA1A310B85}"/>
+                <a16:creationId xmlns:a16="http://schemas.microsoft.com/office/drawing/2014/main" id="{CB0F4B44-97FF-4CF9-83C0-E5EADD6F6DC4}"/>
               </a:ext>
             </a:extLst>
           </p:cNvPr>
@@ -8025,7 +8025,7 @@
           <p:nvPr/>
         </p:nvPicPr>
         <p:blipFill>
-          <a:blip xmlns:r="http://schemas.openxmlformats.org/officeDocument/2006/relationships" xmlns:a="http://schemas.openxmlformats.org/drawingml/2006/main" r:embed="R2c159c15f1394109"/>
+          <a:blip xmlns:r="http://schemas.openxmlformats.org/officeDocument/2006/relationships" xmlns:a="http://schemas.openxmlformats.org/drawingml/2006/main" r:embed="Ra5bfa9321f774723"/>
           <a:stretch xmlns:a="http://schemas.openxmlformats.org/drawingml/2006/main"/>
         </p:blipFill>
         <p:spPr>
@@ -8043,7 +8043,7 @@
           <p:cNvPr id="7" name="">
             <a:extLst xmlns:a="http://schemas.openxmlformats.org/drawingml/2006/main">
               <a:ext uri="{FF2B5EF4-FFF2-40B4-BE49-F238E27FC236}">
-                <a16:creationId xmlns:a16="http://schemas.microsoft.com/office/drawing/2014/main" id="{52422E19-B88D-4C41-806F-3402EBA46AB3}"/>
+                <a16:creationId xmlns:a16="http://schemas.microsoft.com/office/drawing/2014/main" id="{E81F0B58-1394-4C8B-A20C-8C031B5F05CA}"/>
               </a:ext>
             </a:extLst>
           </p:cNvPr>
@@ -8199,7 +8199,7 @@
     </p:spTree>
     <p:extLst>
       <p:ext uri="{BB962C8B-B14F-4D97-AF65-F5344CB8AC3E}">
-        <p14:creationId xmlns:p14="http://schemas.microsoft.com/office/powerpoint/2010/main" val="265888516"/>
+        <p14:creationId xmlns:p14="http://schemas.microsoft.com/office/powerpoint/2010/main" val="1672966593"/>
       </p:ext>
     </p:extLst>
   </p:cSld>
@@ -8230,7 +8230,7 @@
           <p:cNvPr id="9" name="">
             <a:extLst xmlns:a="http://schemas.openxmlformats.org/drawingml/2006/main">
               <a:ext uri="{FF2B5EF4-FFF2-40B4-BE49-F238E27FC236}">
-                <a16:creationId xmlns:a16="http://schemas.microsoft.com/office/drawing/2014/main" id="{DA68C30F-2E05-4009-9C49-8EA5D1D9244A}"/>
+                <a16:creationId xmlns:a16="http://schemas.microsoft.com/office/drawing/2014/main" id="{E72245C4-BB20-46DF-8C78-9EE560D2F6BE}"/>
               </a:ext>
             </a:extLst>
           </p:cNvPr>
@@ -8388,7 +8388,7 @@
           <p:cNvPr id="2" name="">
             <a:extLst xmlns:a="http://schemas.openxmlformats.org/drawingml/2006/main">
               <a:ext uri="{FF2B5EF4-FFF2-40B4-BE49-F238E27FC236}">
-                <a16:creationId xmlns:a16="http://schemas.microsoft.com/office/drawing/2014/main" id="{AFA5F96A-A86C-427E-B724-59E3828A5924}"/>
+                <a16:creationId xmlns:a16="http://schemas.microsoft.com/office/drawing/2014/main" id="{0B0C610F-0E49-4F1C-99F8-6E004F5D851D}"/>
               </a:ext>
             </a:extLst>
           </p:cNvPr>
@@ -8546,7 +8546,7 @@
           <p:cNvPr id="3" name="">
             <a:extLst xmlns:a="http://schemas.openxmlformats.org/drawingml/2006/main">
               <a:ext uri="{FF2B5EF4-FFF2-40B4-BE49-F238E27FC236}">
-                <a16:creationId xmlns:a16="http://schemas.microsoft.com/office/drawing/2014/main" id="{30933E52-0FAB-48A7-BCC1-A4B963B600B8}"/>
+                <a16:creationId xmlns:a16="http://schemas.microsoft.com/office/drawing/2014/main" id="{ACDE863D-85FF-4C25-A945-C16EF60DA68D}"/>
               </a:ext>
             </a:extLst>
           </p:cNvPr>
@@ -8704,7 +8704,7 @@
           <p:cNvPr id="4" name="">
             <a:extLst xmlns:a="http://schemas.openxmlformats.org/drawingml/2006/main">
               <a:ext uri="{FF2B5EF4-FFF2-40B4-BE49-F238E27FC236}">
-                <a16:creationId xmlns:a16="http://schemas.microsoft.com/office/drawing/2014/main" id="{E140073A-3945-4A3B-B6CC-6294BB97CEF7}"/>
+                <a16:creationId xmlns:a16="http://schemas.microsoft.com/office/drawing/2014/main" id="{5AA5B19C-B7FB-41A7-8B29-A112EF83CF19}"/>
               </a:ext>
             </a:extLst>
           </p:cNvPr>
@@ -8862,7 +8862,7 @@
           <p:cNvPr id="5" name="">
             <a:extLst xmlns:a="http://schemas.openxmlformats.org/drawingml/2006/main">
               <a:ext uri="{FF2B5EF4-FFF2-40B4-BE49-F238E27FC236}">
-                <a16:creationId xmlns:a16="http://schemas.microsoft.com/office/drawing/2014/main" id="{EC0D04D0-F467-462A-A7CD-5E9D176DA7B0}"/>
+                <a16:creationId xmlns:a16="http://schemas.microsoft.com/office/drawing/2014/main" id="{FDAF8C0A-3F5E-4731-95FD-FB908A84EB9E}"/>
               </a:ext>
             </a:extLst>
           </p:cNvPr>
@@ -9020,7 +9020,7 @@
           <p:cNvPr id="6" name="">
             <a:extLst xmlns:a="http://schemas.openxmlformats.org/drawingml/2006/main">
               <a:ext uri="{FF2B5EF4-FFF2-40B4-BE49-F238E27FC236}">
-                <a16:creationId xmlns:a16="http://schemas.microsoft.com/office/drawing/2014/main" id="{3D80DA38-B5BA-42C5-A4F5-AE3582858518}"/>
+                <a16:creationId xmlns:a16="http://schemas.microsoft.com/office/drawing/2014/main" id="{CA58A0B9-B1BF-4CAB-B6B8-78FD677B8742}"/>
               </a:ext>
             </a:extLst>
           </p:cNvPr>
@@ -9178,7 +9178,7 @@
           <p:cNvPr id="7" name="">
             <a:extLst xmlns:a="http://schemas.openxmlformats.org/drawingml/2006/main">
               <a:ext uri="{FF2B5EF4-FFF2-40B4-BE49-F238E27FC236}">
-                <a16:creationId xmlns:a16="http://schemas.microsoft.com/office/drawing/2014/main" id="{1EA7327A-3FF0-4F52-9816-F0D301B47B01}"/>
+                <a16:creationId xmlns:a16="http://schemas.microsoft.com/office/drawing/2014/main" id="{4731711C-457A-4477-8C01-8528095AE94B}"/>
               </a:ext>
             </a:extLst>
           </p:cNvPr>
@@ -9188,7 +9188,7 @@
           <p:nvPr/>
         </p:nvPicPr>
         <p:blipFill>
-          <a:blip xmlns:r="http://schemas.openxmlformats.org/officeDocument/2006/relationships" xmlns:a="http://schemas.openxmlformats.org/drawingml/2006/main" r:embed="Rad361146c22240e0"/>
+          <a:blip xmlns:r="http://schemas.openxmlformats.org/officeDocument/2006/relationships" xmlns:a="http://schemas.openxmlformats.org/drawingml/2006/main" r:embed="R9994fdbc0ace4875"/>
           <a:stretch xmlns:a="http://schemas.openxmlformats.org/drawingml/2006/main"/>
         </p:blipFill>
         <p:spPr>
@@ -9206,7 +9206,7 @@
           <p:cNvPr id="8" name="">
             <a:extLst xmlns:a="http://schemas.openxmlformats.org/drawingml/2006/main">
               <a:ext uri="{FF2B5EF4-FFF2-40B4-BE49-F238E27FC236}">
-                <a16:creationId xmlns:a16="http://schemas.microsoft.com/office/drawing/2014/main" id="{6DF3992E-0616-4A73-B5D6-21A51E6B997D}"/>
+                <a16:creationId xmlns:a16="http://schemas.microsoft.com/office/drawing/2014/main" id="{3FFE5DD4-1BCF-42A0-BD91-D74A5ADCFD0D}"/>
               </a:ext>
             </a:extLst>
           </p:cNvPr>
@@ -9362,7 +9362,7 @@
     </p:spTree>
     <p:extLst>
       <p:ext uri="{BB962C8B-B14F-4D97-AF65-F5344CB8AC3E}">
-        <p14:creationId xmlns:p14="http://schemas.microsoft.com/office/powerpoint/2010/main" val="1725996414"/>
+        <p14:creationId xmlns:p14="http://schemas.microsoft.com/office/powerpoint/2010/main" val="1017515217"/>
       </p:ext>
     </p:extLst>
   </p:cSld>
@@ -9393,7 +9393,7 @@
           <p:cNvPr id="9" name="">
             <a:extLst xmlns:a="http://schemas.openxmlformats.org/drawingml/2006/main">
               <a:ext uri="{FF2B5EF4-FFF2-40B4-BE49-F238E27FC236}">
-                <a16:creationId xmlns:a16="http://schemas.microsoft.com/office/drawing/2014/main" id="{5AEC6E90-0333-43ED-B1E4-7A1FCA12F38B}"/>
+                <a16:creationId xmlns:a16="http://schemas.microsoft.com/office/drawing/2014/main" id="{9355FC18-D790-433A-8406-E226D826DD4C}"/>
               </a:ext>
             </a:extLst>
           </p:cNvPr>
@@ -9551,7 +9551,7 @@
           <p:cNvPr id="2" name="">
             <a:extLst xmlns:a="http://schemas.openxmlformats.org/drawingml/2006/main">
               <a:ext uri="{FF2B5EF4-FFF2-40B4-BE49-F238E27FC236}">
-                <a16:creationId xmlns:a16="http://schemas.microsoft.com/office/drawing/2014/main" id="{1CFF079E-1B4C-4CCC-9E33-87DDB93C8ED0}"/>
+                <a16:creationId xmlns:a16="http://schemas.microsoft.com/office/drawing/2014/main" id="{4EE53968-F0A8-44D0-84CE-870662BE84BA}"/>
               </a:ext>
             </a:extLst>
           </p:cNvPr>
@@ -9709,7 +9709,7 @@
           <p:cNvPr id="3" name="">
             <a:extLst xmlns:a="http://schemas.openxmlformats.org/drawingml/2006/main">
               <a:ext uri="{FF2B5EF4-FFF2-40B4-BE49-F238E27FC236}">
-                <a16:creationId xmlns:a16="http://schemas.microsoft.com/office/drawing/2014/main" id="{46845810-DD1A-49BB-9F77-7B3498C50BC3}"/>
+                <a16:creationId xmlns:a16="http://schemas.microsoft.com/office/drawing/2014/main" id="{07D22DAC-AF4E-4C22-84EC-83208CEE48A6}"/>
               </a:ext>
             </a:extLst>
           </p:cNvPr>
@@ -9867,7 +9867,7 @@
           <p:cNvPr id="4" name="">
             <a:extLst xmlns:a="http://schemas.openxmlformats.org/drawingml/2006/main">
               <a:ext uri="{FF2B5EF4-FFF2-40B4-BE49-F238E27FC236}">
-                <a16:creationId xmlns:a16="http://schemas.microsoft.com/office/drawing/2014/main" id="{D8385162-7A50-44C3-B3B0-C3DC0993B135}"/>
+                <a16:creationId xmlns:a16="http://schemas.microsoft.com/office/drawing/2014/main" id="{9836A9EB-1D7C-4D99-A9B4-814364842579}"/>
               </a:ext>
             </a:extLst>
           </p:cNvPr>
@@ -10025,7 +10025,7 @@
           <p:cNvPr id="5" name="">
             <a:extLst xmlns:a="http://schemas.openxmlformats.org/drawingml/2006/main">
               <a:ext uri="{FF2B5EF4-FFF2-40B4-BE49-F238E27FC236}">
-                <a16:creationId xmlns:a16="http://schemas.microsoft.com/office/drawing/2014/main" id="{DB57463F-6E8B-40F3-B089-801F37DA32D0}"/>
+                <a16:creationId xmlns:a16="http://schemas.microsoft.com/office/drawing/2014/main" id="{B6CF5064-BCC0-4891-9AD6-C08B50E061E2}"/>
               </a:ext>
             </a:extLst>
           </p:cNvPr>
@@ -10183,7 +10183,7 @@
           <p:cNvPr id="6" name="">
             <a:extLst xmlns:a="http://schemas.openxmlformats.org/drawingml/2006/main">
               <a:ext uri="{FF2B5EF4-FFF2-40B4-BE49-F238E27FC236}">
-                <a16:creationId xmlns:a16="http://schemas.microsoft.com/office/drawing/2014/main" id="{F3F22FC5-F5A6-4D90-BE12-F9A878215507}"/>
+                <a16:creationId xmlns:a16="http://schemas.microsoft.com/office/drawing/2014/main" id="{62FD7D6C-3E6E-4E02-BDE9-B0F4B4E1BBE4}"/>
               </a:ext>
             </a:extLst>
           </p:cNvPr>
@@ -10341,7 +10341,7 @@
           <p:cNvPr id="7" name="">
             <a:extLst xmlns:a="http://schemas.openxmlformats.org/drawingml/2006/main">
               <a:ext uri="{FF2B5EF4-FFF2-40B4-BE49-F238E27FC236}">
-                <a16:creationId xmlns:a16="http://schemas.microsoft.com/office/drawing/2014/main" id="{40AB9246-D5EB-4110-8FE4-BADDAE49B2C1}"/>
+                <a16:creationId xmlns:a16="http://schemas.microsoft.com/office/drawing/2014/main" id="{489F6C06-B623-4150-AE0C-B1AE4D92E657}"/>
               </a:ext>
             </a:extLst>
           </p:cNvPr>
@@ -10351,7 +10351,7 @@
           <p:nvPr/>
         </p:nvPicPr>
         <p:blipFill>
-          <a:blip xmlns:r="http://schemas.openxmlformats.org/officeDocument/2006/relationships" xmlns:a="http://schemas.openxmlformats.org/drawingml/2006/main" r:embed="Rd75f1d9acf09438b"/>
+          <a:blip xmlns:r="http://schemas.openxmlformats.org/officeDocument/2006/relationships" xmlns:a="http://schemas.openxmlformats.org/drawingml/2006/main" r:embed="R81848188327f4794"/>
           <a:stretch xmlns:a="http://schemas.openxmlformats.org/drawingml/2006/main"/>
         </p:blipFill>
         <p:spPr>
@@ -10369,7 +10369,7 @@
           <p:cNvPr id="8" name="">
             <a:extLst xmlns:a="http://schemas.openxmlformats.org/drawingml/2006/main">
               <a:ext uri="{FF2B5EF4-FFF2-40B4-BE49-F238E27FC236}">
-                <a16:creationId xmlns:a16="http://schemas.microsoft.com/office/drawing/2014/main" id="{032F8637-083B-4203-9E86-9DD6944C4301}"/>
+                <a16:creationId xmlns:a16="http://schemas.microsoft.com/office/drawing/2014/main" id="{80ED558F-AE44-4F56-B27B-6ED0AF174486}"/>
               </a:ext>
             </a:extLst>
           </p:cNvPr>
@@ -10525,7 +10525,7 @@
     </p:spTree>
     <p:extLst>
       <p:ext uri="{BB962C8B-B14F-4D97-AF65-F5344CB8AC3E}">
-        <p14:creationId xmlns:p14="http://schemas.microsoft.com/office/powerpoint/2010/main" val="326611188"/>
+        <p14:creationId xmlns:p14="http://schemas.microsoft.com/office/powerpoint/2010/main" val="1420455190"/>
       </p:ext>
     </p:extLst>
   </p:cSld>
@@ -10556,7 +10556,7 @@
           <p:cNvPr id="8" name="">
             <a:extLst xmlns:a="http://schemas.openxmlformats.org/drawingml/2006/main">
               <a:ext uri="{FF2B5EF4-FFF2-40B4-BE49-F238E27FC236}">
-                <a16:creationId xmlns:a16="http://schemas.microsoft.com/office/drawing/2014/main" id="{C8300118-E816-434F-B07E-6A2315AC83FD}"/>
+                <a16:creationId xmlns:a16="http://schemas.microsoft.com/office/drawing/2014/main" id="{049123D3-980C-43EC-B5D0-6500DF85934C}"/>
               </a:ext>
             </a:extLst>
           </p:cNvPr>
@@ -10714,7 +10714,7 @@
           <p:cNvPr id="2" name="">
             <a:extLst xmlns:a="http://schemas.openxmlformats.org/drawingml/2006/main">
               <a:ext uri="{FF2B5EF4-FFF2-40B4-BE49-F238E27FC236}">
-                <a16:creationId xmlns:a16="http://schemas.microsoft.com/office/drawing/2014/main" id="{A4E6A55D-B877-4142-943E-EBB66468D263}"/>
+                <a16:creationId xmlns:a16="http://schemas.microsoft.com/office/drawing/2014/main" id="{D9D605C1-91FC-4B49-BC4B-8F77F2582C71}"/>
               </a:ext>
             </a:extLst>
           </p:cNvPr>
@@ -10872,7 +10872,7 @@
           <p:cNvPr id="3" name="">
             <a:extLst xmlns:a="http://schemas.openxmlformats.org/drawingml/2006/main">
               <a:ext uri="{FF2B5EF4-FFF2-40B4-BE49-F238E27FC236}">
-                <a16:creationId xmlns:a16="http://schemas.microsoft.com/office/drawing/2014/main" id="{F5E27744-D079-48BF-BF0D-37BE4AFDDEA4}"/>
+                <a16:creationId xmlns:a16="http://schemas.microsoft.com/office/drawing/2014/main" id="{8B084C56-BD13-4104-9294-1F66C2A11DB4}"/>
               </a:ext>
             </a:extLst>
           </p:cNvPr>
@@ -11030,7 +11030,7 @@
           <p:cNvPr id="4" name="">
             <a:extLst xmlns:a="http://schemas.openxmlformats.org/drawingml/2006/main">
               <a:ext uri="{FF2B5EF4-FFF2-40B4-BE49-F238E27FC236}">
-                <a16:creationId xmlns:a16="http://schemas.microsoft.com/office/drawing/2014/main" id="{E2A91193-3F71-4FD1-9F73-991ED9C25187}"/>
+                <a16:creationId xmlns:a16="http://schemas.microsoft.com/office/drawing/2014/main" id="{540242F3-522B-4308-A07B-5E216244CDB7}"/>
               </a:ext>
             </a:extLst>
           </p:cNvPr>
@@ -11188,7 +11188,7 @@
           <p:cNvPr id="5" name="">
             <a:extLst xmlns:a="http://schemas.openxmlformats.org/drawingml/2006/main">
               <a:ext uri="{FF2B5EF4-FFF2-40B4-BE49-F238E27FC236}">
-                <a16:creationId xmlns:a16="http://schemas.microsoft.com/office/drawing/2014/main" id="{1F92F1E8-C07E-4124-AB4E-004F7FC8B4C0}"/>
+                <a16:creationId xmlns:a16="http://schemas.microsoft.com/office/drawing/2014/main" id="{7F42F888-E3CC-4A5F-B683-8A1A652E375C}"/>
               </a:ext>
             </a:extLst>
           </p:cNvPr>
@@ -11346,7 +11346,7 @@
           <p:cNvPr id="6" name="">
             <a:extLst xmlns:a="http://schemas.openxmlformats.org/drawingml/2006/main">
               <a:ext uri="{FF2B5EF4-FFF2-40B4-BE49-F238E27FC236}">
-                <a16:creationId xmlns:a16="http://schemas.microsoft.com/office/drawing/2014/main" id="{81D3F78C-804C-4A46-985E-9D4CD2775D76}"/>
+                <a16:creationId xmlns:a16="http://schemas.microsoft.com/office/drawing/2014/main" id="{6A4ACCB9-2633-428F-8959-1E7FECA757BF}"/>
               </a:ext>
             </a:extLst>
           </p:cNvPr>
@@ -11504,7 +11504,7 @@
           <p:cNvPr id="7" name="">
             <a:extLst xmlns:a="http://schemas.openxmlformats.org/drawingml/2006/main">
               <a:ext uri="{FF2B5EF4-FFF2-40B4-BE49-F238E27FC236}">
-                <a16:creationId xmlns:a16="http://schemas.microsoft.com/office/drawing/2014/main" id="{ACE23093-C557-48D0-AABD-6A37E3369756}"/>
+                <a16:creationId xmlns:a16="http://schemas.microsoft.com/office/drawing/2014/main" id="{2BA52AA2-38EF-48DB-8F8E-D20083676FE7}"/>
               </a:ext>
             </a:extLst>
           </p:cNvPr>
@@ -11660,7 +11660,7 @@
     </p:spTree>
     <p:extLst>
       <p:ext uri="{BB962C8B-B14F-4D97-AF65-F5344CB8AC3E}">
-        <p14:creationId xmlns:p14="http://schemas.microsoft.com/office/powerpoint/2010/main" val="417213402"/>
+        <p14:creationId xmlns:p14="http://schemas.microsoft.com/office/powerpoint/2010/main" val="835559859"/>
       </p:ext>
     </p:extLst>
   </p:cSld>
@@ -11691,7 +11691,7 @@
           <p:cNvPr id="9" name="">
             <a:extLst xmlns:a="http://schemas.openxmlformats.org/drawingml/2006/main">
               <a:ext uri="{FF2B5EF4-FFF2-40B4-BE49-F238E27FC236}">
-                <a16:creationId xmlns:a16="http://schemas.microsoft.com/office/drawing/2014/main" id="{D5F125D5-617A-4984-99B2-EB9ECD4AFABC}"/>
+                <a16:creationId xmlns:a16="http://schemas.microsoft.com/office/drawing/2014/main" id="{0DC64ED5-0D64-47FE-86BE-3E60883E88FC}"/>
               </a:ext>
             </a:extLst>
           </p:cNvPr>
@@ -11849,7 +11849,7 @@
           <p:cNvPr id="2" name="">
             <a:extLst xmlns:a="http://schemas.openxmlformats.org/drawingml/2006/main">
               <a:ext uri="{FF2B5EF4-FFF2-40B4-BE49-F238E27FC236}">
-                <a16:creationId xmlns:a16="http://schemas.microsoft.com/office/drawing/2014/main" id="{7B7F51CE-56CD-45A4-B43E-9DDCFEB12238}"/>
+                <a16:creationId xmlns:a16="http://schemas.microsoft.com/office/drawing/2014/main" id="{1658FC8D-4BE1-4945-8116-038924A56334}"/>
               </a:ext>
             </a:extLst>
           </p:cNvPr>
@@ -12007,7 +12007,7 @@
           <p:cNvPr id="3" name="">
             <a:extLst xmlns:a="http://schemas.openxmlformats.org/drawingml/2006/main">
               <a:ext uri="{FF2B5EF4-FFF2-40B4-BE49-F238E27FC236}">
-                <a16:creationId xmlns:a16="http://schemas.microsoft.com/office/drawing/2014/main" id="{757C7524-04B4-4EA7-BE85-F37068AA9260}"/>
+                <a16:creationId xmlns:a16="http://schemas.microsoft.com/office/drawing/2014/main" id="{B760485C-1C78-4002-B77C-9533C53FD025}"/>
               </a:ext>
             </a:extLst>
           </p:cNvPr>
@@ -12165,7 +12165,7 @@
           <p:cNvPr id="4" name="">
             <a:extLst xmlns:a="http://schemas.openxmlformats.org/drawingml/2006/main">
               <a:ext uri="{FF2B5EF4-FFF2-40B4-BE49-F238E27FC236}">
-                <a16:creationId xmlns:a16="http://schemas.microsoft.com/office/drawing/2014/main" id="{070B42D0-C9FE-4E03-B800-86056653FA64}"/>
+                <a16:creationId xmlns:a16="http://schemas.microsoft.com/office/drawing/2014/main" id="{636C5C5A-86CE-435B-8892-C0236A9A4C81}"/>
               </a:ext>
             </a:extLst>
           </p:cNvPr>
@@ -12323,7 +12323,7 @@
           <p:cNvPr id="5" name="">
             <a:extLst xmlns:a="http://schemas.openxmlformats.org/drawingml/2006/main">
               <a:ext uri="{FF2B5EF4-FFF2-40B4-BE49-F238E27FC236}">
-                <a16:creationId xmlns:a16="http://schemas.microsoft.com/office/drawing/2014/main" id="{FACF12C3-E5CB-4679-AEF3-EF7C843B9AB8}"/>
+                <a16:creationId xmlns:a16="http://schemas.microsoft.com/office/drawing/2014/main" id="{C7D9D442-B012-4363-8F73-8C180EFAA12E}"/>
               </a:ext>
             </a:extLst>
           </p:cNvPr>
@@ -12481,7 +12481,7 @@
           <p:cNvPr id="6" name="">
             <a:extLst xmlns:a="http://schemas.openxmlformats.org/drawingml/2006/main">
               <a:ext uri="{FF2B5EF4-FFF2-40B4-BE49-F238E27FC236}">
-                <a16:creationId xmlns:a16="http://schemas.microsoft.com/office/drawing/2014/main" id="{52203C3A-0DAE-454A-8F3F-2A9B4F5E10C1}"/>
+                <a16:creationId xmlns:a16="http://schemas.microsoft.com/office/drawing/2014/main" id="{7D15C307-5089-459A-B9DC-19106A604CD7}"/>
               </a:ext>
             </a:extLst>
           </p:cNvPr>
@@ -12639,7 +12639,7 @@
           <p:cNvPr id="7" name="">
             <a:extLst xmlns:a="http://schemas.openxmlformats.org/drawingml/2006/main">
               <a:ext uri="{FF2B5EF4-FFF2-40B4-BE49-F238E27FC236}">
-                <a16:creationId xmlns:a16="http://schemas.microsoft.com/office/drawing/2014/main" id="{8F7B3950-D70A-42DF-9202-C0517FFED682}"/>
+                <a16:creationId xmlns:a16="http://schemas.microsoft.com/office/drawing/2014/main" id="{796D0330-0416-42A3-A08F-C6EEEE250CFA}"/>
               </a:ext>
             </a:extLst>
           </p:cNvPr>
@@ -12649,7 +12649,7 @@
           <p:nvPr/>
         </p:nvPicPr>
         <p:blipFill>
-          <a:blip xmlns:r="http://schemas.openxmlformats.org/officeDocument/2006/relationships" xmlns:a="http://schemas.openxmlformats.org/drawingml/2006/main" r:embed="R8dbf191aa0e44bd2"/>
+          <a:blip xmlns:r="http://schemas.openxmlformats.org/officeDocument/2006/relationships" xmlns:a="http://schemas.openxmlformats.org/drawingml/2006/main" r:embed="Ra714172c0c034001"/>
           <a:stretch xmlns:a="http://schemas.openxmlformats.org/drawingml/2006/main"/>
         </p:blipFill>
         <p:spPr>
@@ -12667,7 +12667,7 @@
           <p:cNvPr id="8" name="">
             <a:extLst xmlns:a="http://schemas.openxmlformats.org/drawingml/2006/main">
               <a:ext uri="{FF2B5EF4-FFF2-40B4-BE49-F238E27FC236}">
-                <a16:creationId xmlns:a16="http://schemas.microsoft.com/office/drawing/2014/main" id="{D24A1041-6892-4992-91DE-D107CD42EE37}"/>
+                <a16:creationId xmlns:a16="http://schemas.microsoft.com/office/drawing/2014/main" id="{FA2DAB5F-9C2C-463A-A138-78D3AFFE0E25}"/>
               </a:ext>
             </a:extLst>
           </p:cNvPr>
@@ -12823,7 +12823,7 @@
     </p:spTree>
     <p:extLst>
       <p:ext uri="{BB962C8B-B14F-4D97-AF65-F5344CB8AC3E}">
-        <p14:creationId xmlns:p14="http://schemas.microsoft.com/office/powerpoint/2010/main" val="478118447"/>
+        <p14:creationId xmlns:p14="http://schemas.microsoft.com/office/powerpoint/2010/main" val="1873053460"/>
       </p:ext>
     </p:extLst>
   </p:cSld>
@@ -12854,7 +12854,7 @@
           <p:cNvPr id="9" name="">
             <a:extLst xmlns:a="http://schemas.openxmlformats.org/drawingml/2006/main">
               <a:ext uri="{FF2B5EF4-FFF2-40B4-BE49-F238E27FC236}">
-                <a16:creationId xmlns:a16="http://schemas.microsoft.com/office/drawing/2014/main" id="{3FDF5EE7-17DE-44A9-806E-A21F25924CC1}"/>
+                <a16:creationId xmlns:a16="http://schemas.microsoft.com/office/drawing/2014/main" id="{B71053CE-FD7D-4571-B728-F9941934050A}"/>
               </a:ext>
             </a:extLst>
           </p:cNvPr>
@@ -13012,7 +13012,7 @@
           <p:cNvPr id="2" name="">
             <a:extLst xmlns:a="http://schemas.openxmlformats.org/drawingml/2006/main">
               <a:ext uri="{FF2B5EF4-FFF2-40B4-BE49-F238E27FC236}">
-                <a16:creationId xmlns:a16="http://schemas.microsoft.com/office/drawing/2014/main" id="{767B96FC-E2A0-4452-9433-865CE580991F}"/>
+                <a16:creationId xmlns:a16="http://schemas.microsoft.com/office/drawing/2014/main" id="{7FB5C9B1-1D06-4474-A03F-CB888FB6F000}"/>
               </a:ext>
             </a:extLst>
           </p:cNvPr>
@@ -13170,7 +13170,7 @@
           <p:cNvPr id="3" name="">
             <a:extLst xmlns:a="http://schemas.openxmlformats.org/drawingml/2006/main">
               <a:ext uri="{FF2B5EF4-FFF2-40B4-BE49-F238E27FC236}">
-                <a16:creationId xmlns:a16="http://schemas.microsoft.com/office/drawing/2014/main" id="{90FE0BDA-FC92-4C12-9B84-2BB6DD6C5D54}"/>
+                <a16:creationId xmlns:a16="http://schemas.microsoft.com/office/drawing/2014/main" id="{B7F20A29-8BD2-49D2-AF4A-216A7CE1C075}"/>
               </a:ext>
             </a:extLst>
           </p:cNvPr>
@@ -13328,7 +13328,7 @@
           <p:cNvPr id="4" name="">
             <a:extLst xmlns:a="http://schemas.openxmlformats.org/drawingml/2006/main">
               <a:ext uri="{FF2B5EF4-FFF2-40B4-BE49-F238E27FC236}">
-                <a16:creationId xmlns:a16="http://schemas.microsoft.com/office/drawing/2014/main" id="{D8B4371F-E5F2-4967-AD10-57D772460145}"/>
+                <a16:creationId xmlns:a16="http://schemas.microsoft.com/office/drawing/2014/main" id="{BCA2F89A-F68C-46B6-AB66-B2BF79ABC34F}"/>
               </a:ext>
             </a:extLst>
           </p:cNvPr>
@@ -13486,7 +13486,7 @@
           <p:cNvPr id="5" name="">
             <a:extLst xmlns:a="http://schemas.openxmlformats.org/drawingml/2006/main">
               <a:ext uri="{FF2B5EF4-FFF2-40B4-BE49-F238E27FC236}">
-                <a16:creationId xmlns:a16="http://schemas.microsoft.com/office/drawing/2014/main" id="{338F93E1-75D9-4D90-B89E-116922CCBC75}"/>
+                <a16:creationId xmlns:a16="http://schemas.microsoft.com/office/drawing/2014/main" id="{38E63ABB-EE35-4A8F-B05B-904374FD72E0}"/>
               </a:ext>
             </a:extLst>
           </p:cNvPr>
@@ -13644,7 +13644,7 @@
           <p:cNvPr id="6" name="">
             <a:extLst xmlns:a="http://schemas.openxmlformats.org/drawingml/2006/main">
               <a:ext uri="{FF2B5EF4-FFF2-40B4-BE49-F238E27FC236}">
-                <a16:creationId xmlns:a16="http://schemas.microsoft.com/office/drawing/2014/main" id="{6646B2F6-025B-4EF9-9D66-E913F6DBB155}"/>
+                <a16:creationId xmlns:a16="http://schemas.microsoft.com/office/drawing/2014/main" id="{1C1C2554-18CB-42AD-88E7-DCD510C6CABD}"/>
               </a:ext>
             </a:extLst>
           </p:cNvPr>
@@ -13802,7 +13802,7 @@
           <p:cNvPr id="7" name="">
             <a:extLst xmlns:a="http://schemas.openxmlformats.org/drawingml/2006/main">
               <a:ext uri="{FF2B5EF4-FFF2-40B4-BE49-F238E27FC236}">
-                <a16:creationId xmlns:a16="http://schemas.microsoft.com/office/drawing/2014/main" id="{4B18563C-670A-4E3B-A0D2-5361BBBFFE1F}"/>
+                <a16:creationId xmlns:a16="http://schemas.microsoft.com/office/drawing/2014/main" id="{A7185953-B61E-4CFB-8B9C-7C2A5F11F8A4}"/>
               </a:ext>
             </a:extLst>
           </p:cNvPr>
@@ -13812,13 +13812,13 @@
           <p:nvPr/>
         </p:nvPicPr>
         <p:blipFill>
-          <a:blip xmlns:r="http://schemas.openxmlformats.org/officeDocument/2006/relationships" xmlns:a="http://schemas.openxmlformats.org/drawingml/2006/main" r:embed="R0de4e8be4fc6418e"/>
+          <a:blip xmlns:r="http://schemas.openxmlformats.org/officeDocument/2006/relationships" xmlns:a="http://schemas.openxmlformats.org/drawingml/2006/main" r:embed="Rb3b5843270754ca1"/>
           <a:stretch xmlns:a="http://schemas.openxmlformats.org/drawingml/2006/main"/>
         </p:blipFill>
         <p:spPr>
           <a:xfrm xmlns:a="http://schemas.openxmlformats.org/drawingml/2006/main">
-            <a:off x="4429125" y="2580968"/>
-            <a:ext cx="7143750" cy="2458065"/>
+            <a:off x="4514850" y="1381125"/>
+            <a:ext cx="6972300" cy="4857750"/>
           </a:xfrm>
           <a:prstGeom xmlns:a="http://schemas.openxmlformats.org/drawingml/2006/main" prst="rect">
             <a:avLst/>
@@ -13830,7 +13830,7 @@
           <p:cNvPr id="8" name="">
             <a:extLst xmlns:a="http://schemas.openxmlformats.org/drawingml/2006/main">
               <a:ext uri="{FF2B5EF4-FFF2-40B4-BE49-F238E27FC236}">
-                <a16:creationId xmlns:a16="http://schemas.microsoft.com/office/drawing/2014/main" id="{AA28BD44-D5F7-45DE-AF66-06687B248CA8}"/>
+                <a16:creationId xmlns:a16="http://schemas.microsoft.com/office/drawing/2014/main" id="{81DB6A3D-23F0-4C47-A56A-C14482EED81D}"/>
               </a:ext>
             </a:extLst>
           </p:cNvPr>
@@ -13986,7 +13986,7 @@
     </p:spTree>
     <p:extLst>
       <p:ext uri="{BB962C8B-B14F-4D97-AF65-F5344CB8AC3E}">
-        <p14:creationId xmlns:p14="http://schemas.microsoft.com/office/powerpoint/2010/main" val="265704214"/>
+        <p14:creationId xmlns:p14="http://schemas.microsoft.com/office/powerpoint/2010/main" val="1930360409"/>
       </p:ext>
     </p:extLst>
   </p:cSld>
@@ -14017,7 +14017,7 @@
           <p:cNvPr id="9" name="">
             <a:extLst xmlns:a="http://schemas.openxmlformats.org/drawingml/2006/main">
               <a:ext uri="{FF2B5EF4-FFF2-40B4-BE49-F238E27FC236}">
-                <a16:creationId xmlns:a16="http://schemas.microsoft.com/office/drawing/2014/main" id="{CC59DAB0-78AA-42A3-B72D-45ABD44C7BE7}"/>
+                <a16:creationId xmlns:a16="http://schemas.microsoft.com/office/drawing/2014/main" id="{1D613283-34BE-4564-8330-71D292EBD4FB}"/>
               </a:ext>
             </a:extLst>
           </p:cNvPr>
@@ -14175,7 +14175,7 @@
           <p:cNvPr id="2" name="">
             <a:extLst xmlns:a="http://schemas.openxmlformats.org/drawingml/2006/main">
               <a:ext uri="{FF2B5EF4-FFF2-40B4-BE49-F238E27FC236}">
-                <a16:creationId xmlns:a16="http://schemas.microsoft.com/office/drawing/2014/main" id="{BA5E26AA-FAA9-46A9-BEAC-47DB96D3AE62}"/>
+                <a16:creationId xmlns:a16="http://schemas.microsoft.com/office/drawing/2014/main" id="{4AE22F9C-9A71-410A-B941-555D1AC9DD1F}"/>
               </a:ext>
             </a:extLst>
           </p:cNvPr>
@@ -14333,7 +14333,7 @@
           <p:cNvPr id="3" name="">
             <a:extLst xmlns:a="http://schemas.openxmlformats.org/drawingml/2006/main">
               <a:ext uri="{FF2B5EF4-FFF2-40B4-BE49-F238E27FC236}">
-                <a16:creationId xmlns:a16="http://schemas.microsoft.com/office/drawing/2014/main" id="{C81172DD-B8CF-48E3-BE19-C3844F60E05C}"/>
+                <a16:creationId xmlns:a16="http://schemas.microsoft.com/office/drawing/2014/main" id="{881B31C6-4BC8-4F9F-92C1-CE1639A26841}"/>
               </a:ext>
             </a:extLst>
           </p:cNvPr>
@@ -14491,7 +14491,7 @@
           <p:cNvPr id="4" name="">
             <a:extLst xmlns:a="http://schemas.openxmlformats.org/drawingml/2006/main">
               <a:ext uri="{FF2B5EF4-FFF2-40B4-BE49-F238E27FC236}">
-                <a16:creationId xmlns:a16="http://schemas.microsoft.com/office/drawing/2014/main" id="{A8612563-E9A3-47C2-AD23-4D90865447D7}"/>
+                <a16:creationId xmlns:a16="http://schemas.microsoft.com/office/drawing/2014/main" id="{3C2C3D7F-DA1C-41FF-8D2D-8ED47853E8CE}"/>
               </a:ext>
             </a:extLst>
           </p:cNvPr>
@@ -14649,7 +14649,7 @@
           <p:cNvPr id="5" name="">
             <a:extLst xmlns:a="http://schemas.openxmlformats.org/drawingml/2006/main">
               <a:ext uri="{FF2B5EF4-FFF2-40B4-BE49-F238E27FC236}">
-                <a16:creationId xmlns:a16="http://schemas.microsoft.com/office/drawing/2014/main" id="{65506C06-886B-4391-930C-3B9129B61514}"/>
+                <a16:creationId xmlns:a16="http://schemas.microsoft.com/office/drawing/2014/main" id="{9F44D87B-3A3D-4603-944B-A4CA253D4FFE}"/>
               </a:ext>
             </a:extLst>
           </p:cNvPr>
@@ -14807,7 +14807,7 @@
           <p:cNvPr id="6" name="">
             <a:extLst xmlns:a="http://schemas.openxmlformats.org/drawingml/2006/main">
               <a:ext uri="{FF2B5EF4-FFF2-40B4-BE49-F238E27FC236}">
-                <a16:creationId xmlns:a16="http://schemas.microsoft.com/office/drawing/2014/main" id="{DECA6DA8-AAD6-421A-A766-371516107715}"/>
+                <a16:creationId xmlns:a16="http://schemas.microsoft.com/office/drawing/2014/main" id="{3805CEB9-3139-490F-96E3-DFA32342CF65}"/>
               </a:ext>
             </a:extLst>
           </p:cNvPr>
@@ -14965,7 +14965,7 @@
           <p:cNvPr id="7" name="">
             <a:extLst xmlns:a="http://schemas.openxmlformats.org/drawingml/2006/main">
               <a:ext uri="{FF2B5EF4-FFF2-40B4-BE49-F238E27FC236}">
-                <a16:creationId xmlns:a16="http://schemas.microsoft.com/office/drawing/2014/main" id="{993214D2-D73F-4C52-9C2A-CD74100105C7}"/>
+                <a16:creationId xmlns:a16="http://schemas.microsoft.com/office/drawing/2014/main" id="{E19A266E-759F-4AB5-9419-C0FE83D5B891}"/>
               </a:ext>
             </a:extLst>
           </p:cNvPr>
@@ -14975,7 +14975,7 @@
           <p:nvPr/>
         </p:nvPicPr>
         <p:blipFill>
-          <a:blip xmlns:r="http://schemas.openxmlformats.org/officeDocument/2006/relationships" xmlns:a="http://schemas.openxmlformats.org/drawingml/2006/main" r:embed="Re939ff761e2245ca"/>
+          <a:blip xmlns:r="http://schemas.openxmlformats.org/officeDocument/2006/relationships" xmlns:a="http://schemas.openxmlformats.org/drawingml/2006/main" r:embed="R2fc506a5b7a14dc1"/>
           <a:stretch xmlns:a="http://schemas.openxmlformats.org/drawingml/2006/main"/>
         </p:blipFill>
         <p:spPr>
@@ -14993,7 +14993,7 @@
           <p:cNvPr id="8" name="">
             <a:extLst xmlns:a="http://schemas.openxmlformats.org/drawingml/2006/main">
               <a:ext uri="{FF2B5EF4-FFF2-40B4-BE49-F238E27FC236}">
-                <a16:creationId xmlns:a16="http://schemas.microsoft.com/office/drawing/2014/main" id="{30249455-7862-44CD-B908-0E626C60D169}"/>
+                <a16:creationId xmlns:a16="http://schemas.microsoft.com/office/drawing/2014/main" id="{73474E1B-6208-430A-BF98-26BAC97309DE}"/>
               </a:ext>
             </a:extLst>
           </p:cNvPr>
@@ -15149,7 +15149,7 @@
     </p:spTree>
     <p:extLst>
       <p:ext uri="{BB962C8B-B14F-4D97-AF65-F5344CB8AC3E}">
-        <p14:creationId xmlns:p14="http://schemas.microsoft.com/office/powerpoint/2010/main" val="756018556"/>
+        <p14:creationId xmlns:p14="http://schemas.microsoft.com/office/powerpoint/2010/main" val="1112958653"/>
       </p:ext>
     </p:extLst>
   </p:cSld>

</xml_diff>